<commit_message>
T3/T4 complete: archive metrics+figures, add event-level backup slides to deck
T3: learned MET (tracks+cells) 27.0+-0.1 GeV vs 43.2 best classical (-37%);
tracks-only collapses to constant. T4: DETR finder plateau eff 0.99 (TC) vs
0.95 (T), fake 0.11, cells sharpen kinematics; large DETR seed variance noted.

Co-Authored-By: Claude Fable 5 <noreply@anthropic.com>
</commit_message>
<xml_diff>
--- a/talks/2026-08-feasibility-workshop/DFM_feasibility_workshop.pptx
+++ b/talks/2026-08-feasibility-workshop/DFM_feasibility_workshop.pptx
@@ -19,9 +19,12 @@
     <p:sldId id="267" r:id="rId13"/>
     <p:sldId id="268" r:id="rId14"/>
     <p:sldId id="269" r:id="rId15"/>
+    <p:sldId id="270" r:id="rId16"/>
+    <p:sldId id="271" r:id="rId17"/>
+    <p:sldId id="272" r:id="rId18"/>
   </p:sldIdLst>
   <p:notesMasterIdLst>
-    <p:notesMasterId r:id="rId16"/>
+    <p:notesMasterId r:id="rId19"/>
   </p:notesMasterIdLst>
   <p:sldSz cx="12192000" cy="6858000"/>
   <p:notesSz cx="6858000" cy="12192000"/>
@@ -979,6 +982,270 @@
             <a:fld id="{F7021451-1387-4CA6-816F-3879F97B5CBC}" type="slidenum">
               <a:rPr lang="en-US"/>
               <a:t>14</a:t>
+            </a:fld>
+            <a:endParaRPr lang="en-US"/>
+          </a:p>
+        </p:txBody>
+      </p:sp>
+    </p:spTree>
+    <p:extLst>
+      <p:ext uri="{BB962C8B-B14F-4D97-AF65-F5344CB8AC3E}">
+        <p14:creationId xmlns:p14="http://schemas.microsoft.com/office/powerpoint/2010/main" val="1024086991"/>
+      </p:ext>
+    </p:extLst>
+  </p:cSld>
+  <p:clrMapOvr>
+    <a:masterClrMapping/>
+  </p:clrMapOvr>
+</p:notes>
+</file>
+
+<file path=ppt/notesSlides/notesSlide15.xml><?xml version="1.0" encoding="utf-8"?>
+<p:notes xmlns:a="http://schemas.openxmlformats.org/drawingml/2006/main" xmlns:r="http://schemas.openxmlformats.org/officeDocument/2006/relationships" xmlns:p="http://schemas.openxmlformats.org/presentationml/2006/main">
+  <p:cSld>
+    <p:spTree>
+      <p:nvGrpSpPr>
+        <p:cNvPr id="1" name=""/>
+        <p:cNvGrpSpPr/>
+        <p:nvPr/>
+      </p:nvGrpSpPr>
+      <p:grpSpPr>
+        <a:xfrm>
+          <a:off x="0" y="0"/>
+          <a:ext cx="0" cy="0"/>
+          <a:chOff x="0" y="0"/>
+          <a:chExt cx="0" cy="0"/>
+        </a:xfrm>
+      </p:grpSpPr>
+      <p:sp>
+        <p:nvSpPr>
+          <p:cNvPr id="2" name="Slide Image Placeholder 1"/>
+          <p:cNvSpPr>
+            <a:spLocks noGrp="1" noRot="1" noChangeAspect="1"/>
+          </p:cNvSpPr>
+          <p:nvPr>
+            <p:ph type="sldImg"/>
+          </p:nvPr>
+        </p:nvSpPr>
+        <p:spPr/>
+      </p:sp>
+      <p:sp>
+        <p:nvSpPr>
+          <p:cNvPr id="3" name="Notes Placeholder 2"/>
+          <p:cNvSpPr>
+            <a:spLocks noGrp="1"/>
+          </p:cNvSpPr>
+          <p:nvPr>
+            <p:ph type="body" idx="1"/>
+          </p:nvPr>
+        </p:nvSpPr>
+        <p:spPr/>
+        <p:txBody>
+          <a:bodyPr/>
+          <a:lstStyle/>
+          <a:p>
+            <a:r>
+              <a:rPr lang="en-US" dirty="0"/>
+              <a:t>The learned MET is better everywhere, and dramatically so at high true MET where the cell sum fails. The tracks-only row is the interesting negative result — covered on the next slide.</a:t>
+            </a:r>
+            <a:endParaRPr lang="en-US" dirty="0"/>
+          </a:p>
+        </p:txBody>
+      </p:sp>
+      <p:sp>
+        <p:nvSpPr>
+          <p:cNvPr id="4" name="Slide Number Placeholder 3"/>
+          <p:cNvSpPr>
+            <a:spLocks noGrp="1"/>
+          </p:cNvSpPr>
+          <p:nvPr>
+            <p:ph type="sldNum" sz="quarter" idx="10"/>
+          </p:nvPr>
+        </p:nvSpPr>
+        <p:spPr/>
+        <p:txBody>
+          <a:bodyPr/>
+          <a:lstStyle/>
+          <a:p>
+            <a:fld id="{F7021451-1387-4CA6-816F-3879F97B5CBC}" type="slidenum">
+              <a:rPr lang="en-US"/>
+              <a:t>15</a:t>
+            </a:fld>
+            <a:endParaRPr lang="en-US"/>
+          </a:p>
+        </p:txBody>
+      </p:sp>
+    </p:spTree>
+    <p:extLst>
+      <p:ext uri="{BB962C8B-B14F-4D97-AF65-F5344CB8AC3E}">
+        <p14:creationId xmlns:p14="http://schemas.microsoft.com/office/powerpoint/2010/main" val="1024086991"/>
+      </p:ext>
+    </p:extLst>
+  </p:cSld>
+  <p:clrMapOvr>
+    <a:masterClrMapping/>
+  </p:clrMapOvr>
+</p:notes>
+</file>
+
+<file path=ppt/notesSlides/notesSlide16.xml><?xml version="1.0" encoding="utf-8"?>
+<p:notes xmlns:a="http://schemas.openxmlformats.org/drawingml/2006/main" xmlns:r="http://schemas.openxmlformats.org/officeDocument/2006/relationships" xmlns:p="http://schemas.openxmlformats.org/presentationml/2006/main">
+  <p:cSld>
+    <p:spTree>
+      <p:nvGrpSpPr>
+        <p:cNvPr id="1" name=""/>
+        <p:cNvGrpSpPr/>
+        <p:nvPr/>
+      </p:nvGrpSpPr>
+      <p:grpSpPr>
+        <a:xfrm>
+          <a:off x="0" y="0"/>
+          <a:ext cx="0" cy="0"/>
+          <a:chOff x="0" y="0"/>
+          <a:chExt cx="0" cy="0"/>
+        </a:xfrm>
+      </p:grpSpPr>
+      <p:sp>
+        <p:nvSpPr>
+          <p:cNvPr id="2" name="Slide Image Placeholder 1"/>
+          <p:cNvSpPr>
+            <a:spLocks noGrp="1" noRot="1" noChangeAspect="1"/>
+          </p:cNvSpPr>
+          <p:nvPr>
+            <p:ph type="sldImg"/>
+          </p:nvPr>
+        </p:nvSpPr>
+        <p:spPr/>
+      </p:sp>
+      <p:sp>
+        <p:nvSpPr>
+          <p:cNvPr id="3" name="Notes Placeholder 2"/>
+          <p:cNvSpPr>
+            <a:spLocks noGrp="1"/>
+          </p:cNvSpPr>
+          <p:nvPr>
+            <p:ph type="body" idx="1"/>
+          </p:nvPr>
+        </p:nvSpPr>
+        <p:spPr/>
+        <p:txBody>
+          <a:bodyPr/>
+          <a:lstStyle/>
+          <a:p>
+            <a:r>
+              <a:rPr lang="en-US" dirty="0"/>
+              <a:t/>
+            </a:r>
+            <a:endParaRPr lang="en-US" dirty="0"/>
+          </a:p>
+        </p:txBody>
+      </p:sp>
+      <p:sp>
+        <p:nvSpPr>
+          <p:cNvPr id="4" name="Slide Number Placeholder 3"/>
+          <p:cNvSpPr>
+            <a:spLocks noGrp="1"/>
+          </p:cNvSpPr>
+          <p:nvPr>
+            <p:ph type="sldNum" sz="quarter" idx="10"/>
+          </p:nvPr>
+        </p:nvSpPr>
+        <p:spPr/>
+        <p:txBody>
+          <a:bodyPr/>
+          <a:lstStyle/>
+          <a:p>
+            <a:fld id="{F7021451-1387-4CA6-816F-3879F97B5CBC}" type="slidenum">
+              <a:rPr lang="en-US"/>
+              <a:t>16</a:t>
+            </a:fld>
+            <a:endParaRPr lang="en-US"/>
+          </a:p>
+        </p:txBody>
+      </p:sp>
+    </p:spTree>
+    <p:extLst>
+      <p:ext uri="{BB962C8B-B14F-4D97-AF65-F5344CB8AC3E}">
+        <p14:creationId xmlns:p14="http://schemas.microsoft.com/office/powerpoint/2010/main" val="1024086991"/>
+      </p:ext>
+    </p:extLst>
+  </p:cSld>
+  <p:clrMapOvr>
+    <a:masterClrMapping/>
+  </p:clrMapOvr>
+</p:notes>
+</file>
+
+<file path=ppt/notesSlides/notesSlide17.xml><?xml version="1.0" encoding="utf-8"?>
+<p:notes xmlns:a="http://schemas.openxmlformats.org/drawingml/2006/main" xmlns:r="http://schemas.openxmlformats.org/officeDocument/2006/relationships" xmlns:p="http://schemas.openxmlformats.org/presentationml/2006/main">
+  <p:cSld>
+    <p:spTree>
+      <p:nvGrpSpPr>
+        <p:cNvPr id="1" name=""/>
+        <p:cNvGrpSpPr/>
+        <p:nvPr/>
+      </p:nvGrpSpPr>
+      <p:grpSpPr>
+        <a:xfrm>
+          <a:off x="0" y="0"/>
+          <a:ext cx="0" cy="0"/>
+          <a:chOff x="0" y="0"/>
+          <a:chExt cx="0" cy="0"/>
+        </a:xfrm>
+      </p:grpSpPr>
+      <p:sp>
+        <p:nvSpPr>
+          <p:cNvPr id="2" name="Slide Image Placeholder 1"/>
+          <p:cNvSpPr>
+            <a:spLocks noGrp="1" noRot="1" noChangeAspect="1"/>
+          </p:cNvSpPr>
+          <p:nvPr>
+            <p:ph type="sldImg"/>
+          </p:nvPr>
+        </p:nvSpPr>
+        <p:spPr/>
+      </p:sp>
+      <p:sp>
+        <p:nvSpPr>
+          <p:cNvPr id="3" name="Notes Placeholder 2"/>
+          <p:cNvSpPr>
+            <a:spLocks noGrp="1"/>
+          </p:cNvSpPr>
+          <p:nvPr>
+            <p:ph type="body" idx="1"/>
+          </p:nvPr>
+        </p:nvSpPr>
+        <p:spPr/>
+        <p:txBody>
+          <a:bodyPr/>
+          <a:lstStyle/>
+          <a:p>
+            <a:r>
+              <a:rPr lang="en-US" dirty="0"/>
+              <a:t>One shared encoder does event-level set prediction out of the box. The efficiency turn-on at low pT and the DETR seed variance are both expected at this scale and are the first things the scaled study should attack.</a:t>
+            </a:r>
+            <a:endParaRPr lang="en-US" dirty="0"/>
+          </a:p>
+        </p:txBody>
+      </p:sp>
+      <p:sp>
+        <p:nvSpPr>
+          <p:cNvPr id="4" name="Slide Number Placeholder 3"/>
+          <p:cNvSpPr>
+            <a:spLocks noGrp="1"/>
+          </p:cNvSpPr>
+          <p:nvPr>
+            <p:ph type="sldNum" sz="quarter" idx="10"/>
+          </p:nvPr>
+        </p:nvSpPr>
+        <p:spPr/>
+        <p:txBody>
+          <a:bodyPr/>
+          <a:lstStyle/>
+          <a:p>
+            <a:fld id="{F7021451-1387-4CA6-816F-3879F97B5CBC}" type="slidenum">
+              <a:rPr lang="en-US"/>
+              <a:t>17</a:t>
             </a:fld>
             <a:endParaRPr lang="en-US"/>
           </a:p>
@@ -2383,7 +2650,7 @@
                 <a:ea typeface="Calibri" pitchFamily="34" charset="-122"/>
                 <a:cs typeface="Calibri" pitchFamily="34" charset="-120"/>
               </a:rPr>
-              <a:t>~100</a:t>
+              <a:t>~115</a:t>
             </a:r>
             <a:endParaRPr lang="en-US" sz="3800" dirty="0"/>
           </a:p>
@@ -2425,7 +2692,7 @@
                 <a:ea typeface="Calibri" pitchFamily="34" charset="-122"/>
                 <a:cs typeface="Calibri" pitchFamily="34" charset="-120"/>
               </a:rPr>
-              <a:t>trainings across five gated study campaigns</a:t>
+              <a:t>trainings across six gated study campaigns</a:t>
             </a:r>
             <a:endParaRPr lang="en-US" sz="1100" dirty="0"/>
           </a:p>
@@ -3607,7 +3874,7 @@
                 <a:ea typeface="Calibri" pitchFamily="34" charset="-122"/>
                 <a:cs typeface="Calibri" pitchFamily="34" charset="-120"/>
               </a:rPr>
-              <a:t>Training now: MET regression (T3) and DETR-style jet finding (T4)</a:t>
+              <a:t>New: learned MET beats classical estimates by 37% (T3); one-shot DETR jet finding demonstrated (T4) — backup slides</a:t>
             </a:r>
             <a:endParaRPr lang="en-US" sz="1150" dirty="0"/>
           </a:p>
@@ -3979,7 +4246,7 @@
                 <a:ea typeface="Calibri" pitchFamily="34" charset="-122"/>
                 <a:cs typeface="Calibri" pitchFamily="34" charset="-120"/>
               </a:rPr>
-              <a:t>Measuring jet energy scale, resolution, and uncertainty honesty</a:t>
+              <a:t>Measuring jet energy scale, resolution, and uncertainty honesty · event-level results (T3 MET, T4 jet finding)</a:t>
             </a:r>
             <a:endParaRPr lang="en-US" sz="1700" dirty="0"/>
           </a:p>
@@ -5822,6 +6089,2921 @@
                 <a:cs typeface="Calibri" pitchFamily="34" charset="-120"/>
               </a:rPr>
               <a:t>14</a:t>
+            </a:r>
+            <a:endParaRPr lang="en-US" sz="900" dirty="0"/>
+          </a:p>
+        </p:txBody>
+      </p:sp>
+    </p:spTree>
+  </p:cSld>
+  <p:clrMapOvr>
+    <a:masterClrMapping/>
+  </p:clrMapOvr>
+</p:sld>
+</file>
+
+<file path=ppt/slides/slide15.xml><?xml version="1.0" encoding="utf-8"?>
+<p:sld xmlns:a="http://schemas.openxmlformats.org/drawingml/2006/main" xmlns:r="http://schemas.openxmlformats.org/officeDocument/2006/relationships" xmlns:p="http://schemas.openxmlformats.org/presentationml/2006/main">
+  <p:cSld name="Slide 15">
+    <p:spTree>
+      <p:nvGrpSpPr>
+        <p:cNvPr id="1" name=""/>
+        <p:cNvGrpSpPr/>
+        <p:nvPr/>
+      </p:nvGrpSpPr>
+      <p:grpSpPr>
+        <a:xfrm>
+          <a:off x="0" y="0"/>
+          <a:ext cx="0" cy="0"/>
+          <a:chOff x="0" y="0"/>
+          <a:chExt cx="0" cy="0"/>
+        </a:xfrm>
+      </p:grpSpPr>
+      <p:sp>
+        <p:nvSpPr>
+          <p:cNvPr id="2" name="Text 0"/>
+          <p:cNvSpPr/>
+          <p:nvPr/>
+        </p:nvSpPr>
+        <p:spPr>
+          <a:xfrm>
+            <a:off x="502920" y="256032"/>
+            <a:ext cx="11155680" cy="274320"/>
+          </a:xfrm>
+          <a:prstGeom prst="rect">
+            <a:avLst/>
+          </a:prstGeom>
+          <a:noFill/>
+          <a:ln/>
+        </p:spPr>
+        <p:txBody>
+          <a:bodyPr wrap="square" lIns="0" tIns="0" rIns="0" bIns="0" rtlCol="0" anchor="ctr"/>
+          <a:lstStyle/>
+          <a:p>
+            <a:pPr indent="0" marL="0">
+              <a:buNone/>
+            </a:pPr>
+            <a:r>
+              <a:rPr lang="en-US" sz="1050" b="1" spc="200" kern="0" dirty="0">
+                <a:solidFill>
+                  <a:srgbClr val="667085"/>
+                </a:solidFill>
+                <a:latin typeface="Calibri" pitchFamily="34" charset="0"/>
+                <a:ea typeface="Calibri" pitchFamily="34" charset="-122"/>
+                <a:cs typeface="Calibri" pitchFamily="34" charset="-120"/>
+              </a:rPr>
+              <a:t>BACKUP — EVENT-LEVEL TASKS</a:t>
+            </a:r>
+            <a:endParaRPr lang="en-US" sz="1050" dirty="0"/>
+          </a:p>
+        </p:txBody>
+      </p:sp>
+      <p:sp>
+        <p:nvSpPr>
+          <p:cNvPr id="3" name="Text 1"/>
+          <p:cNvSpPr/>
+          <p:nvPr/>
+        </p:nvSpPr>
+        <p:spPr>
+          <a:xfrm>
+            <a:off x="502920" y="475488"/>
+            <a:ext cx="11155680" cy="566928"/>
+          </a:xfrm>
+          <a:prstGeom prst="rect">
+            <a:avLst/>
+          </a:prstGeom>
+          <a:noFill/>
+          <a:ln/>
+        </p:spPr>
+        <p:txBody>
+          <a:bodyPr wrap="square" lIns="0" tIns="0" rIns="0" bIns="0" rtlCol="0" anchor="ctr"/>
+          <a:lstStyle/>
+          <a:p>
+            <a:pPr indent="0" marL="0">
+              <a:buNone/>
+            </a:pPr>
+            <a:r>
+              <a:rPr lang="en-US" sz="2700" b="1" dirty="0">
+                <a:solidFill>
+                  <a:srgbClr val="1E2761"/>
+                </a:solidFill>
+                <a:latin typeface="Calibri" pitchFamily="34" charset="0"/>
+                <a:ea typeface="Calibri" pitchFamily="34" charset="-122"/>
+                <a:cs typeface="Calibri" pitchFamily="34" charset="-120"/>
+              </a:rPr>
+              <a:t>T3: MET estimation from tracks + cells</a:t>
+            </a:r>
+            <a:endParaRPr lang="en-US" sz="2700" dirty="0"/>
+          </a:p>
+        </p:txBody>
+      </p:sp>
+      <p:sp>
+        <p:nvSpPr>
+          <p:cNvPr id="4" name="Text 2"/>
+          <p:cNvSpPr/>
+          <p:nvPr/>
+        </p:nvSpPr>
+        <p:spPr>
+          <a:xfrm>
+            <a:off x="502920" y="1234440"/>
+            <a:ext cx="5806440" cy="2286000"/>
+          </a:xfrm>
+          <a:prstGeom prst="rect">
+            <a:avLst/>
+          </a:prstGeom>
+          <a:noFill/>
+          <a:ln/>
+        </p:spPr>
+        <p:txBody>
+          <a:bodyPr wrap="square" lIns="0" tIns="0" rIns="0" bIns="0" rtlCol="0" anchor="t"/>
+          <a:lstStyle/>
+          <a:p>
+            <a:pPr marL="127000" indent="-127000">
+              <a:lnSpc>
+                <a:spcPct val="107000"/>
+              </a:lnSpc>
+              <a:buSzPct val="100000"/>
+              <a:buChar char="•"/>
+            </a:pPr>
+            <a:r>
+              <a:rPr lang="en-US" sz="1200" b="1" dirty="0">
+                <a:solidFill>
+                  <a:srgbClr val="1E2761"/>
+                </a:solidFill>
+                <a:latin typeface="Calibri" pitchFamily="34" charset="0"/>
+                <a:ea typeface="Calibri" pitchFamily="34" charset="-122"/>
+                <a:cs typeface="Calibri" pitchFamily="34" charset="-120"/>
+              </a:rPr>
+              <a:t>Target:</a:t>
+            </a:r>
+            <a:pPr indent="0" marL="0">
+              <a:lnSpc>
+                <a:spcPct val="107000"/>
+              </a:lnSpc>
+              <a:spcAft>
+                <a:spcPts val="800"/>
+              </a:spcAft>
+              <a:buNone/>
+            </a:pPr>
+            <a:r>
+              <a:rPr lang="en-US" sz="1200" dirty="0">
+                <a:solidFill>
+                  <a:srgbClr val="232833"/>
+                </a:solidFill>
+                <a:latin typeface="Calibri" pitchFamily="34" charset="0"/>
+                <a:ea typeface="Calibri" pitchFamily="34" charset="-122"/>
+                <a:cs typeface="Calibri" pitchFamily="34" charset="-120"/>
+              </a:rPr>
+              <a:t> truth MET = vector sum of truth-record neutrinos. One sample = one event: all PV/unassociated tracks (pT &gt; 0.5 GeV, ≤500) and all matched cells with the transferred event neighbor subgraph.</a:t>
+            </a:r>
+            <a:endParaRPr lang="en-US" sz="1200" dirty="0"/>
+          </a:p>
+          <a:p>
+            <a:pPr marL="127000" indent="-127000">
+              <a:lnSpc>
+                <a:spcPct val="107000"/>
+              </a:lnSpc>
+              <a:buSzPct val="100000"/>
+              <a:buChar char="•"/>
+            </a:pPr>
+            <a:r>
+              <a:rPr lang="en-US" sz="1200" b="1" dirty="0">
+                <a:solidFill>
+                  <a:srgbClr val="1E2761"/>
+                </a:solidFill>
+                <a:latin typeface="Calibri" pitchFamily="34" charset="0"/>
+                <a:ea typeface="Calibri" pitchFamily="34" charset="-122"/>
+                <a:cs typeface="Calibri" pitchFamily="34" charset="-120"/>
+              </a:rPr>
+              <a:t>Head:</a:t>
+            </a:r>
+            <a:pPr indent="0" marL="0">
+              <a:lnSpc>
+                <a:spcPct val="107000"/>
+              </a:lnSpc>
+              <a:spcAft>
+                <a:spcPts val="800"/>
+              </a:spcAft>
+              <a:buNone/>
+            </a:pPr>
+            <a:r>
+              <a:rPr lang="en-US" sz="1200" dirty="0">
+                <a:solidFill>
+                  <a:srgbClr val="232833"/>
+                </a:solidFill>
+                <a:latin typeface="Calibri" pitchFamily="34" charset="0"/>
+                <a:ea typeface="Calibri" pitchFamily="34" charset="-122"/>
+                <a:cs typeface="Calibri" pitchFamily="34" charset="-120"/>
+              </a:rPr>
+              <a:t> pooled global token → (MET_x, MET_y); Huber loss on MET/100 GeV.</a:t>
+            </a:r>
+            <a:endParaRPr lang="en-US" sz="1200" dirty="0"/>
+          </a:p>
+          <a:p>
+            <a:pPr marL="127000" indent="-127000">
+              <a:lnSpc>
+                <a:spcPct val="107000"/>
+              </a:lnSpc>
+              <a:buSzPct val="100000"/>
+              <a:buChar char="•"/>
+            </a:pPr>
+            <a:r>
+              <a:rPr lang="en-US" sz="1200" b="1" dirty="0">
+                <a:solidFill>
+                  <a:srgbClr val="1E2761"/>
+                </a:solidFill>
+                <a:latin typeface="Calibri" pitchFamily="34" charset="0"/>
+                <a:ea typeface="Calibri" pitchFamily="34" charset="-122"/>
+                <a:cs typeface="Calibri" pitchFamily="34" charset="-120"/>
+              </a:rPr>
+              <a:t>Baselines:</a:t>
+            </a:r>
+            <a:pPr indent="0" marL="0">
+              <a:lnSpc>
+                <a:spcPct val="107000"/>
+              </a:lnSpc>
+              <a:spcAft>
+                <a:spcPts val="800"/>
+              </a:spcAft>
+              <a:buNone/>
+            </a:pPr>
+            <a:r>
+              <a:rPr lang="en-US" sz="1200" dirty="0">
+                <a:solidFill>
+                  <a:srgbClr val="232833"/>
+                </a:solidFill>
+                <a:latin typeface="Calibri" pitchFamily="34" charset="0"/>
+                <a:ea typeface="Calibri" pitchFamily="34" charset="-122"/>
+                <a:cs typeface="Calibri" pitchFamily="34" charset="-120"/>
+              </a:rPr>
+              <a:t> negative vector sums of tracks / cells / matched jets, computed on the identical test events.</a:t>
+            </a:r>
+            <a:endParaRPr lang="en-US" sz="1200" dirty="0"/>
+          </a:p>
+        </p:txBody>
+      </p:sp>
+      <p:graphicFrame>
+        <p:nvGraphicFramePr>
+          <p:cNvPr id="16" name="Table 0"/>
+          <p:cNvGraphicFramePr>
+            <a:graphicFrameLocks noGrp="1"/>
+          </p:cNvGraphicFramePr>
+          <p:nvPr>
+            <p:extLst>
+              <p:ext uri="{D42A27DB-BD31-4B8C-83A1-F6EECF244321}">
+                <p14:modId xmlns:p14="http://schemas.microsoft.com/office/powerpoint/2010/main" val="1579011935"/>
+              </p:ext>
+            </p:extLst>
+          </p:nvPr>
+        </p:nvGraphicFramePr>
+        <p:xfrm>
+          <a:off x="502920" y="3657600"/>
+          <a:ext cx="5806440" cy="914400"/>
+        </p:xfrm>
+        <a:graphic>
+          <a:graphicData uri="http://schemas.openxmlformats.org/drawingml/2006/table">
+            <a:tbl>
+              <a:tblPr/>
+              <a:tblGrid>
+                <a:gridCol w="2103120"/>
+                <a:gridCol w="3703320"/>
+              </a:tblGrid>
+              <a:tr h="329184">
+                <a:tc>
+                  <a:txBody>
+                    <a:bodyPr/>
+                    <a:lstStyle/>
+                    <a:p>
+                      <a:pPr indent="0" marL="0">
+                        <a:buNone/>
+                      </a:pPr>
+                      <a:r>
+                        <a:rPr lang="en-US" sz="1050" b="1" dirty="0">
+                          <a:solidFill>
+                            <a:srgbClr val="FFFFFF"/>
+                          </a:solidFill>
+                          <a:latin typeface="Calibri" pitchFamily="34" charset="0"/>
+                          <a:ea typeface="Calibri" pitchFamily="34" charset="-122"/>
+                          <a:cs typeface="Calibri" pitchFamily="34" charset="-120"/>
+                        </a:rPr>
+                        <a:t>Estimator</a:t>
+                      </a:r>
+                      <a:endParaRPr lang="en-US" sz="1050" dirty="0">
+                        <a:latin typeface="Calibri" charset="0"/>
+                        <a:ea typeface="Calibri" charset="0"/>
+                        <a:cs typeface="Calibri" charset="0"/>
+                      </a:endParaRPr>
+                    </a:p>
+                  </a:txBody>
+                  <a:tcPr marL="45720" marR="45720" marT="45720" marB="45720" anchor="ctr">
+                    <a:lnL w="12700" cap="flat" cmpd="sng" algn="ctr">
+                      <a:solidFill>
+                        <a:srgbClr val="DCE4F0"/>
+                      </a:solidFill>
+                      <a:prstDash val="solid"/>
+                      <a:round/>
+                      <a:headEnd type="none" w="med" len="med"/>
+                      <a:tailEnd type="none" w="med" len="med"/>
+                    </a:lnL>
+                    <a:lnR w="12700" cap="flat" cmpd="sng" algn="ctr">
+                      <a:solidFill>
+                        <a:srgbClr val="DCE4F0"/>
+                      </a:solidFill>
+                      <a:prstDash val="solid"/>
+                      <a:round/>
+                      <a:headEnd type="none" w="med" len="med"/>
+                      <a:tailEnd type="none" w="med" len="med"/>
+                    </a:lnR>
+                    <a:lnT w="12700" cap="flat" cmpd="sng" algn="ctr">
+                      <a:solidFill>
+                        <a:srgbClr val="DCE4F0"/>
+                      </a:solidFill>
+                      <a:prstDash val="solid"/>
+                      <a:round/>
+                      <a:headEnd type="none" w="med" len="med"/>
+                      <a:tailEnd type="none" w="med" len="med"/>
+                    </a:lnT>
+                    <a:lnB w="12700" cap="flat" cmpd="sng" algn="ctr">
+                      <a:solidFill>
+                        <a:srgbClr val="DCE4F0"/>
+                      </a:solidFill>
+                      <a:prstDash val="solid"/>
+                      <a:round/>
+                      <a:headEnd type="none" w="med" len="med"/>
+                      <a:tailEnd type="none" w="med" len="med"/>
+                    </a:lnB>
+                    <a:solidFill>
+                      <a:srgbClr val="1E2761"/>
+                    </a:solidFill>
+                  </a:tcPr>
+                </a:tc>
+                <a:tc>
+                  <a:txBody>
+                    <a:bodyPr/>
+                    <a:lstStyle/>
+                    <a:p>
+                      <a:pPr indent="0" marL="0">
+                        <a:buNone/>
+                      </a:pPr>
+                      <a:r>
+                        <a:rPr lang="en-US" sz="1050" b="1" dirty="0">
+                          <a:solidFill>
+                            <a:srgbClr val="FFFFFF"/>
+                          </a:solidFill>
+                          <a:latin typeface="Calibri" pitchFamily="34" charset="0"/>
+                          <a:ea typeface="Calibri" pitchFamily="34" charset="-122"/>
+                          <a:cs typeface="Calibri" pitchFamily="34" charset="-120"/>
+                        </a:rPr>
+                        <a:t>σ68 per component [GeV]</a:t>
+                      </a:r>
+                      <a:endParaRPr lang="en-US" sz="1050" dirty="0">
+                        <a:latin typeface="Calibri" charset="0"/>
+                        <a:ea typeface="Calibri" charset="0"/>
+                        <a:cs typeface="Calibri" charset="0"/>
+                      </a:endParaRPr>
+                    </a:p>
+                  </a:txBody>
+                  <a:tcPr marL="45720" marR="45720" marT="45720" marB="45720" anchor="ctr">
+                    <a:lnL w="12700" cap="flat" cmpd="sng" algn="ctr">
+                      <a:solidFill>
+                        <a:srgbClr val="DCE4F0"/>
+                      </a:solidFill>
+                      <a:prstDash val="solid"/>
+                      <a:round/>
+                      <a:headEnd type="none" w="med" len="med"/>
+                      <a:tailEnd type="none" w="med" len="med"/>
+                    </a:lnL>
+                    <a:lnR w="12700" cap="flat" cmpd="sng" algn="ctr">
+                      <a:solidFill>
+                        <a:srgbClr val="DCE4F0"/>
+                      </a:solidFill>
+                      <a:prstDash val="solid"/>
+                      <a:round/>
+                      <a:headEnd type="none" w="med" len="med"/>
+                      <a:tailEnd type="none" w="med" len="med"/>
+                    </a:lnR>
+                    <a:lnT w="12700" cap="flat" cmpd="sng" algn="ctr">
+                      <a:solidFill>
+                        <a:srgbClr val="DCE4F0"/>
+                      </a:solidFill>
+                      <a:prstDash val="solid"/>
+                      <a:round/>
+                      <a:headEnd type="none" w="med" len="med"/>
+                      <a:tailEnd type="none" w="med" len="med"/>
+                    </a:lnT>
+                    <a:lnB w="12700" cap="flat" cmpd="sng" algn="ctr">
+                      <a:solidFill>
+                        <a:srgbClr val="DCE4F0"/>
+                      </a:solidFill>
+                      <a:prstDash val="solid"/>
+                      <a:round/>
+                      <a:headEnd type="none" w="med" len="med"/>
+                      <a:tailEnd type="none" w="med" len="med"/>
+                    </a:lnB>
+                    <a:solidFill>
+                      <a:srgbClr val="1E2761"/>
+                    </a:solidFill>
+                  </a:tcPr>
+                </a:tc>
+              </a:tr>
+              <a:tr h="329184">
+                <a:tc>
+                  <a:txBody>
+                    <a:bodyPr/>
+                    <a:lstStyle/>
+                    <a:p>
+                      <a:pPr indent="0" marL="0">
+                        <a:buNone/>
+                      </a:pPr>
+                      <a:r>
+                        <a:rPr lang="en-US" sz="1050" dirty="0">
+                          <a:solidFill>
+                            <a:srgbClr val="232833"/>
+                          </a:solidFill>
+                          <a:latin typeface="Calibri" pitchFamily="34" charset="0"/>
+                          <a:ea typeface="Calibri" pitchFamily="34" charset="-122"/>
+                          <a:cs typeface="Calibri" pitchFamily="34" charset="-120"/>
+                        </a:rPr>
+                        <a:t>track sum</a:t>
+                      </a:r>
+                      <a:endParaRPr lang="en-US" sz="1050" dirty="0">
+                        <a:latin typeface="Calibri" charset="0"/>
+                        <a:ea typeface="Calibri" charset="0"/>
+                        <a:cs typeface="Calibri" charset="0"/>
+                      </a:endParaRPr>
+                    </a:p>
+                  </a:txBody>
+                  <a:tcPr marL="45720" marR="45720" marT="45720" marB="45720" anchor="ctr">
+                    <a:lnL w="12700" cap="flat" cmpd="sng" algn="ctr">
+                      <a:solidFill>
+                        <a:srgbClr val="DCE4F0"/>
+                      </a:solidFill>
+                      <a:prstDash val="solid"/>
+                      <a:round/>
+                      <a:headEnd type="none" w="med" len="med"/>
+                      <a:tailEnd type="none" w="med" len="med"/>
+                    </a:lnL>
+                    <a:lnR w="12700" cap="flat" cmpd="sng" algn="ctr">
+                      <a:solidFill>
+                        <a:srgbClr val="DCE4F0"/>
+                      </a:solidFill>
+                      <a:prstDash val="solid"/>
+                      <a:round/>
+                      <a:headEnd type="none" w="med" len="med"/>
+                      <a:tailEnd type="none" w="med" len="med"/>
+                    </a:lnR>
+                    <a:lnT w="12700" cap="flat" cmpd="sng" algn="ctr">
+                      <a:solidFill>
+                        <a:srgbClr val="DCE4F0"/>
+                      </a:solidFill>
+                      <a:prstDash val="solid"/>
+                      <a:round/>
+                      <a:headEnd type="none" w="med" len="med"/>
+                      <a:tailEnd type="none" w="med" len="med"/>
+                    </a:lnT>
+                    <a:lnB w="12700" cap="flat" cmpd="sng" algn="ctr">
+                      <a:solidFill>
+                        <a:srgbClr val="DCE4F0"/>
+                      </a:solidFill>
+                      <a:prstDash val="solid"/>
+                      <a:round/>
+                      <a:headEnd type="none" w="med" len="med"/>
+                      <a:tailEnd type="none" w="med" len="med"/>
+                    </a:lnB>
+                  </a:tcPr>
+                </a:tc>
+                <a:tc>
+                  <a:txBody>
+                    <a:bodyPr/>
+                    <a:lstStyle/>
+                    <a:p>
+                      <a:pPr indent="0" marL="0">
+                        <a:buNone/>
+                      </a:pPr>
+                      <a:r>
+                        <a:rPr lang="en-US" sz="1050" dirty="0">
+                          <a:solidFill>
+                            <a:srgbClr val="232833"/>
+                          </a:solidFill>
+                          <a:latin typeface="Calibri" pitchFamily="34" charset="0"/>
+                          <a:ea typeface="Calibri" pitchFamily="34" charset="-122"/>
+                          <a:cs typeface="Calibri" pitchFamily="34" charset="-120"/>
+                        </a:rPr>
+                        <a:t>60.6</a:t>
+                      </a:r>
+                      <a:endParaRPr lang="en-US" sz="1050" dirty="0">
+                        <a:latin typeface="Calibri" charset="0"/>
+                        <a:ea typeface="Calibri" charset="0"/>
+                        <a:cs typeface="Calibri" charset="0"/>
+                      </a:endParaRPr>
+                    </a:p>
+                  </a:txBody>
+                  <a:tcPr marL="45720" marR="45720" marT="45720" marB="45720" anchor="ctr">
+                    <a:lnL w="12700" cap="flat" cmpd="sng" algn="ctr">
+                      <a:solidFill>
+                        <a:srgbClr val="DCE4F0"/>
+                      </a:solidFill>
+                      <a:prstDash val="solid"/>
+                      <a:round/>
+                      <a:headEnd type="none" w="med" len="med"/>
+                      <a:tailEnd type="none" w="med" len="med"/>
+                    </a:lnL>
+                    <a:lnR w="12700" cap="flat" cmpd="sng" algn="ctr">
+                      <a:solidFill>
+                        <a:srgbClr val="DCE4F0"/>
+                      </a:solidFill>
+                      <a:prstDash val="solid"/>
+                      <a:round/>
+                      <a:headEnd type="none" w="med" len="med"/>
+                      <a:tailEnd type="none" w="med" len="med"/>
+                    </a:lnR>
+                    <a:lnT w="12700" cap="flat" cmpd="sng" algn="ctr">
+                      <a:solidFill>
+                        <a:srgbClr val="DCE4F0"/>
+                      </a:solidFill>
+                      <a:prstDash val="solid"/>
+                      <a:round/>
+                      <a:headEnd type="none" w="med" len="med"/>
+                      <a:tailEnd type="none" w="med" len="med"/>
+                    </a:lnT>
+                    <a:lnB w="12700" cap="flat" cmpd="sng" algn="ctr">
+                      <a:solidFill>
+                        <a:srgbClr val="DCE4F0"/>
+                      </a:solidFill>
+                      <a:prstDash val="solid"/>
+                      <a:round/>
+                      <a:headEnd type="none" w="med" len="med"/>
+                      <a:tailEnd type="none" w="med" len="med"/>
+                    </a:lnB>
+                  </a:tcPr>
+                </a:tc>
+              </a:tr>
+              <a:tr h="329184">
+                <a:tc>
+                  <a:txBody>
+                    <a:bodyPr/>
+                    <a:lstStyle/>
+                    <a:p>
+                      <a:pPr indent="0" marL="0">
+                        <a:buNone/>
+                      </a:pPr>
+                      <a:r>
+                        <a:rPr lang="en-US" sz="1050" dirty="0">
+                          <a:solidFill>
+                            <a:srgbClr val="232833"/>
+                          </a:solidFill>
+                          <a:latin typeface="Calibri" pitchFamily="34" charset="0"/>
+                          <a:ea typeface="Calibri" pitchFamily="34" charset="-122"/>
+                          <a:cs typeface="Calibri" pitchFamily="34" charset="-120"/>
+                        </a:rPr>
+                        <a:t>cell sum</a:t>
+                      </a:r>
+                      <a:endParaRPr lang="en-US" sz="1050" dirty="0">
+                        <a:latin typeface="Calibri" charset="0"/>
+                        <a:ea typeface="Calibri" charset="0"/>
+                        <a:cs typeface="Calibri" charset="0"/>
+                      </a:endParaRPr>
+                    </a:p>
+                  </a:txBody>
+                  <a:tcPr marL="45720" marR="45720" marT="45720" marB="45720" anchor="ctr">
+                    <a:lnL w="12700" cap="flat" cmpd="sng" algn="ctr">
+                      <a:solidFill>
+                        <a:srgbClr val="DCE4F0"/>
+                      </a:solidFill>
+                      <a:prstDash val="solid"/>
+                      <a:round/>
+                      <a:headEnd type="none" w="med" len="med"/>
+                      <a:tailEnd type="none" w="med" len="med"/>
+                    </a:lnL>
+                    <a:lnR w="12700" cap="flat" cmpd="sng" algn="ctr">
+                      <a:solidFill>
+                        <a:srgbClr val="DCE4F0"/>
+                      </a:solidFill>
+                      <a:prstDash val="solid"/>
+                      <a:round/>
+                      <a:headEnd type="none" w="med" len="med"/>
+                      <a:tailEnd type="none" w="med" len="med"/>
+                    </a:lnR>
+                    <a:lnT w="12700" cap="flat" cmpd="sng" algn="ctr">
+                      <a:solidFill>
+                        <a:srgbClr val="DCE4F0"/>
+                      </a:solidFill>
+                      <a:prstDash val="solid"/>
+                      <a:round/>
+                      <a:headEnd type="none" w="med" len="med"/>
+                      <a:tailEnd type="none" w="med" len="med"/>
+                    </a:lnT>
+                    <a:lnB w="12700" cap="flat" cmpd="sng" algn="ctr">
+                      <a:solidFill>
+                        <a:srgbClr val="DCE4F0"/>
+                      </a:solidFill>
+                      <a:prstDash val="solid"/>
+                      <a:round/>
+                      <a:headEnd type="none" w="med" len="med"/>
+                      <a:tailEnd type="none" w="med" len="med"/>
+                    </a:lnB>
+                  </a:tcPr>
+                </a:tc>
+                <a:tc>
+                  <a:txBody>
+                    <a:bodyPr/>
+                    <a:lstStyle/>
+                    <a:p>
+                      <a:pPr indent="0" marL="0">
+                        <a:buNone/>
+                      </a:pPr>
+                      <a:r>
+                        <a:rPr lang="en-US" sz="1050" dirty="0">
+                          <a:solidFill>
+                            <a:srgbClr val="232833"/>
+                          </a:solidFill>
+                          <a:latin typeface="Calibri" pitchFamily="34" charset="0"/>
+                          <a:ea typeface="Calibri" pitchFamily="34" charset="-122"/>
+                          <a:cs typeface="Calibri" pitchFamily="34" charset="-120"/>
+                        </a:rPr>
+                        <a:t>43.2</a:t>
+                      </a:r>
+                      <a:endParaRPr lang="en-US" sz="1050" dirty="0">
+                        <a:latin typeface="Calibri" charset="0"/>
+                        <a:ea typeface="Calibri" charset="0"/>
+                        <a:cs typeface="Calibri" charset="0"/>
+                      </a:endParaRPr>
+                    </a:p>
+                  </a:txBody>
+                  <a:tcPr marL="45720" marR="45720" marT="45720" marB="45720" anchor="ctr">
+                    <a:lnL w="12700" cap="flat" cmpd="sng" algn="ctr">
+                      <a:solidFill>
+                        <a:srgbClr val="DCE4F0"/>
+                      </a:solidFill>
+                      <a:prstDash val="solid"/>
+                      <a:round/>
+                      <a:headEnd type="none" w="med" len="med"/>
+                      <a:tailEnd type="none" w="med" len="med"/>
+                    </a:lnL>
+                    <a:lnR w="12700" cap="flat" cmpd="sng" algn="ctr">
+                      <a:solidFill>
+                        <a:srgbClr val="DCE4F0"/>
+                      </a:solidFill>
+                      <a:prstDash val="solid"/>
+                      <a:round/>
+                      <a:headEnd type="none" w="med" len="med"/>
+                      <a:tailEnd type="none" w="med" len="med"/>
+                    </a:lnR>
+                    <a:lnT w="12700" cap="flat" cmpd="sng" algn="ctr">
+                      <a:solidFill>
+                        <a:srgbClr val="DCE4F0"/>
+                      </a:solidFill>
+                      <a:prstDash val="solid"/>
+                      <a:round/>
+                      <a:headEnd type="none" w="med" len="med"/>
+                      <a:tailEnd type="none" w="med" len="med"/>
+                    </a:lnT>
+                    <a:lnB w="12700" cap="flat" cmpd="sng" algn="ctr">
+                      <a:solidFill>
+                        <a:srgbClr val="DCE4F0"/>
+                      </a:solidFill>
+                      <a:prstDash val="solid"/>
+                      <a:round/>
+                      <a:headEnd type="none" w="med" len="med"/>
+                      <a:tailEnd type="none" w="med" len="med"/>
+                    </a:lnB>
+                  </a:tcPr>
+                </a:tc>
+              </a:tr>
+              <a:tr h="329184">
+                <a:tc>
+                  <a:txBody>
+                    <a:bodyPr/>
+                    <a:lstStyle/>
+                    <a:p>
+                      <a:pPr indent="0" marL="0">
+                        <a:buNone/>
+                      </a:pPr>
+                      <a:r>
+                        <a:rPr lang="en-US" sz="1050" dirty="0">
+                          <a:solidFill>
+                            <a:srgbClr val="232833"/>
+                          </a:solidFill>
+                          <a:latin typeface="Calibri" pitchFamily="34" charset="0"/>
+                          <a:ea typeface="Calibri" pitchFamily="34" charset="-122"/>
+                          <a:cs typeface="Calibri" pitchFamily="34" charset="-120"/>
+                        </a:rPr>
+                        <a:t>jet sum</a:t>
+                      </a:r>
+                      <a:endParaRPr lang="en-US" sz="1050" dirty="0">
+                        <a:latin typeface="Calibri" charset="0"/>
+                        <a:ea typeface="Calibri" charset="0"/>
+                        <a:cs typeface="Calibri" charset="0"/>
+                      </a:endParaRPr>
+                    </a:p>
+                  </a:txBody>
+                  <a:tcPr marL="45720" marR="45720" marT="45720" marB="45720" anchor="ctr">
+                    <a:lnL w="12700" cap="flat" cmpd="sng" algn="ctr">
+                      <a:solidFill>
+                        <a:srgbClr val="DCE4F0"/>
+                      </a:solidFill>
+                      <a:prstDash val="solid"/>
+                      <a:round/>
+                      <a:headEnd type="none" w="med" len="med"/>
+                      <a:tailEnd type="none" w="med" len="med"/>
+                    </a:lnL>
+                    <a:lnR w="12700" cap="flat" cmpd="sng" algn="ctr">
+                      <a:solidFill>
+                        <a:srgbClr val="DCE4F0"/>
+                      </a:solidFill>
+                      <a:prstDash val="solid"/>
+                      <a:round/>
+                      <a:headEnd type="none" w="med" len="med"/>
+                      <a:tailEnd type="none" w="med" len="med"/>
+                    </a:lnR>
+                    <a:lnT w="12700" cap="flat" cmpd="sng" algn="ctr">
+                      <a:solidFill>
+                        <a:srgbClr val="DCE4F0"/>
+                      </a:solidFill>
+                      <a:prstDash val="solid"/>
+                      <a:round/>
+                      <a:headEnd type="none" w="med" len="med"/>
+                      <a:tailEnd type="none" w="med" len="med"/>
+                    </a:lnT>
+                    <a:lnB w="12700" cap="flat" cmpd="sng" algn="ctr">
+                      <a:solidFill>
+                        <a:srgbClr val="DCE4F0"/>
+                      </a:solidFill>
+                      <a:prstDash val="solid"/>
+                      <a:round/>
+                      <a:headEnd type="none" w="med" len="med"/>
+                      <a:tailEnd type="none" w="med" len="med"/>
+                    </a:lnB>
+                  </a:tcPr>
+                </a:tc>
+                <a:tc>
+                  <a:txBody>
+                    <a:bodyPr/>
+                    <a:lstStyle/>
+                    <a:p>
+                      <a:pPr indent="0" marL="0">
+                        <a:buNone/>
+                      </a:pPr>
+                      <a:r>
+                        <a:rPr lang="en-US" sz="1050" dirty="0">
+                          <a:solidFill>
+                            <a:srgbClr val="232833"/>
+                          </a:solidFill>
+                          <a:latin typeface="Calibri" pitchFamily="34" charset="0"/>
+                          <a:ea typeface="Calibri" pitchFamily="34" charset="-122"/>
+                          <a:cs typeface="Calibri" pitchFamily="34" charset="-120"/>
+                        </a:rPr>
+                        <a:t>44.2</a:t>
+                      </a:r>
+                      <a:endParaRPr lang="en-US" sz="1050" dirty="0">
+                        <a:latin typeface="Calibri" charset="0"/>
+                        <a:ea typeface="Calibri" charset="0"/>
+                        <a:cs typeface="Calibri" charset="0"/>
+                      </a:endParaRPr>
+                    </a:p>
+                  </a:txBody>
+                  <a:tcPr marL="45720" marR="45720" marT="45720" marB="45720" anchor="ctr">
+                    <a:lnL w="12700" cap="flat" cmpd="sng" algn="ctr">
+                      <a:solidFill>
+                        <a:srgbClr val="DCE4F0"/>
+                      </a:solidFill>
+                      <a:prstDash val="solid"/>
+                      <a:round/>
+                      <a:headEnd type="none" w="med" len="med"/>
+                      <a:tailEnd type="none" w="med" len="med"/>
+                    </a:lnL>
+                    <a:lnR w="12700" cap="flat" cmpd="sng" algn="ctr">
+                      <a:solidFill>
+                        <a:srgbClr val="DCE4F0"/>
+                      </a:solidFill>
+                      <a:prstDash val="solid"/>
+                      <a:round/>
+                      <a:headEnd type="none" w="med" len="med"/>
+                      <a:tailEnd type="none" w="med" len="med"/>
+                    </a:lnR>
+                    <a:lnT w="12700" cap="flat" cmpd="sng" algn="ctr">
+                      <a:solidFill>
+                        <a:srgbClr val="DCE4F0"/>
+                      </a:solidFill>
+                      <a:prstDash val="solid"/>
+                      <a:round/>
+                      <a:headEnd type="none" w="med" len="med"/>
+                      <a:tailEnd type="none" w="med" len="med"/>
+                    </a:lnT>
+                    <a:lnB w="12700" cap="flat" cmpd="sng" algn="ctr">
+                      <a:solidFill>
+                        <a:srgbClr val="DCE4F0"/>
+                      </a:solidFill>
+                      <a:prstDash val="solid"/>
+                      <a:round/>
+                      <a:headEnd type="none" w="med" len="med"/>
+                      <a:tailEnd type="none" w="med" len="med"/>
+                    </a:lnB>
+                  </a:tcPr>
+                </a:tc>
+              </a:tr>
+              <a:tr h="329184">
+                <a:tc>
+                  <a:txBody>
+                    <a:bodyPr/>
+                    <a:lstStyle/>
+                    <a:p>
+                      <a:pPr indent="0" marL="0">
+                        <a:buNone/>
+                      </a:pPr>
+                      <a:r>
+                        <a:rPr lang="en-US" sz="1050" dirty="0">
+                          <a:solidFill>
+                            <a:srgbClr val="232833"/>
+                          </a:solidFill>
+                          <a:latin typeface="Calibri" pitchFamily="34" charset="0"/>
+                          <a:ea typeface="Calibri" pitchFamily="34" charset="-122"/>
+                          <a:cs typeface="Calibri" pitchFamily="34" charset="-120"/>
+                        </a:rPr>
+                        <a:t>model, tracks only</a:t>
+                      </a:r>
+                      <a:endParaRPr lang="en-US" sz="1050" dirty="0">
+                        <a:latin typeface="Calibri" charset="0"/>
+                        <a:ea typeface="Calibri" charset="0"/>
+                        <a:cs typeface="Calibri" charset="0"/>
+                      </a:endParaRPr>
+                    </a:p>
+                  </a:txBody>
+                  <a:tcPr marL="45720" marR="45720" marT="45720" marB="45720" anchor="ctr">
+                    <a:lnL w="12700" cap="flat" cmpd="sng" algn="ctr">
+                      <a:solidFill>
+                        <a:srgbClr val="DCE4F0"/>
+                      </a:solidFill>
+                      <a:prstDash val="solid"/>
+                      <a:round/>
+                      <a:headEnd type="none" w="med" len="med"/>
+                      <a:tailEnd type="none" w="med" len="med"/>
+                    </a:lnL>
+                    <a:lnR w="12700" cap="flat" cmpd="sng" algn="ctr">
+                      <a:solidFill>
+                        <a:srgbClr val="DCE4F0"/>
+                      </a:solidFill>
+                      <a:prstDash val="solid"/>
+                      <a:round/>
+                      <a:headEnd type="none" w="med" len="med"/>
+                      <a:tailEnd type="none" w="med" len="med"/>
+                    </a:lnR>
+                    <a:lnT w="12700" cap="flat" cmpd="sng" algn="ctr">
+                      <a:solidFill>
+                        <a:srgbClr val="DCE4F0"/>
+                      </a:solidFill>
+                      <a:prstDash val="solid"/>
+                      <a:round/>
+                      <a:headEnd type="none" w="med" len="med"/>
+                      <a:tailEnd type="none" w="med" len="med"/>
+                    </a:lnT>
+                    <a:lnB w="12700" cap="flat" cmpd="sng" algn="ctr">
+                      <a:solidFill>
+                        <a:srgbClr val="DCE4F0"/>
+                      </a:solidFill>
+                      <a:prstDash val="solid"/>
+                      <a:round/>
+                      <a:headEnd type="none" w="med" len="med"/>
+                      <a:tailEnd type="none" w="med" len="med"/>
+                    </a:lnB>
+                  </a:tcPr>
+                </a:tc>
+                <a:tc>
+                  <a:txBody>
+                    <a:bodyPr/>
+                    <a:lstStyle/>
+                    <a:p>
+                      <a:pPr indent="0" marL="0">
+                        <a:buNone/>
+                      </a:pPr>
+                      <a:r>
+                        <a:rPr lang="en-US" sz="1050" dirty="0">
+                          <a:solidFill>
+                            <a:srgbClr val="232833"/>
+                          </a:solidFill>
+                          <a:latin typeface="Calibri" pitchFamily="34" charset="0"/>
+                          <a:ea typeface="Calibri" pitchFamily="34" charset="-122"/>
+                          <a:cs typeface="Calibri" pitchFamily="34" charset="-120"/>
+                        </a:rPr>
+                        <a:t>49.5 — collapsed to constant output</a:t>
+                      </a:r>
+                      <a:endParaRPr lang="en-US" sz="1050" dirty="0">
+                        <a:latin typeface="Calibri" charset="0"/>
+                        <a:ea typeface="Calibri" charset="0"/>
+                        <a:cs typeface="Calibri" charset="0"/>
+                      </a:endParaRPr>
+                    </a:p>
+                  </a:txBody>
+                  <a:tcPr marL="45720" marR="45720" marT="45720" marB="45720" anchor="ctr">
+                    <a:lnL w="12700" cap="flat" cmpd="sng" algn="ctr">
+                      <a:solidFill>
+                        <a:srgbClr val="DCE4F0"/>
+                      </a:solidFill>
+                      <a:prstDash val="solid"/>
+                      <a:round/>
+                      <a:headEnd type="none" w="med" len="med"/>
+                      <a:tailEnd type="none" w="med" len="med"/>
+                    </a:lnL>
+                    <a:lnR w="12700" cap="flat" cmpd="sng" algn="ctr">
+                      <a:solidFill>
+                        <a:srgbClr val="DCE4F0"/>
+                      </a:solidFill>
+                      <a:prstDash val="solid"/>
+                      <a:round/>
+                      <a:headEnd type="none" w="med" len="med"/>
+                      <a:tailEnd type="none" w="med" len="med"/>
+                    </a:lnR>
+                    <a:lnT w="12700" cap="flat" cmpd="sng" algn="ctr">
+                      <a:solidFill>
+                        <a:srgbClr val="DCE4F0"/>
+                      </a:solidFill>
+                      <a:prstDash val="solid"/>
+                      <a:round/>
+                      <a:headEnd type="none" w="med" len="med"/>
+                      <a:tailEnd type="none" w="med" len="med"/>
+                    </a:lnT>
+                    <a:lnB w="12700" cap="flat" cmpd="sng" algn="ctr">
+                      <a:solidFill>
+                        <a:srgbClr val="DCE4F0"/>
+                      </a:solidFill>
+                      <a:prstDash val="solid"/>
+                      <a:round/>
+                      <a:headEnd type="none" w="med" len="med"/>
+                      <a:tailEnd type="none" w="med" len="med"/>
+                    </a:lnB>
+                  </a:tcPr>
+                </a:tc>
+              </a:tr>
+              <a:tr h="329184">
+                <a:tc>
+                  <a:txBody>
+                    <a:bodyPr/>
+                    <a:lstStyle/>
+                    <a:p>
+                      <a:pPr indent="0" marL="0">
+                        <a:buNone/>
+                      </a:pPr>
+                      <a:r>
+                        <a:rPr lang="en-US" sz="1050" b="1" dirty="0">
+                          <a:solidFill>
+                            <a:srgbClr val="232833"/>
+                          </a:solidFill>
+                          <a:latin typeface="Calibri" pitchFamily="34" charset="0"/>
+                          <a:ea typeface="Calibri" pitchFamily="34" charset="-122"/>
+                          <a:cs typeface="Calibri" pitchFamily="34" charset="-120"/>
+                        </a:rPr>
+                        <a:t>model, tracks + cells</a:t>
+                      </a:r>
+                      <a:endParaRPr lang="en-US" sz="1050" dirty="0">
+                        <a:latin typeface="Calibri" charset="0"/>
+                        <a:ea typeface="Calibri" charset="0"/>
+                        <a:cs typeface="Calibri" charset="0"/>
+                      </a:endParaRPr>
+                    </a:p>
+                  </a:txBody>
+                  <a:tcPr marL="45720" marR="45720" marT="45720" marB="45720" anchor="ctr">
+                    <a:lnL w="12700" cap="flat" cmpd="sng" algn="ctr">
+                      <a:solidFill>
+                        <a:srgbClr val="DCE4F0"/>
+                      </a:solidFill>
+                      <a:prstDash val="solid"/>
+                      <a:round/>
+                      <a:headEnd type="none" w="med" len="med"/>
+                      <a:tailEnd type="none" w="med" len="med"/>
+                    </a:lnL>
+                    <a:lnR w="12700" cap="flat" cmpd="sng" algn="ctr">
+                      <a:solidFill>
+                        <a:srgbClr val="DCE4F0"/>
+                      </a:solidFill>
+                      <a:prstDash val="solid"/>
+                      <a:round/>
+                      <a:headEnd type="none" w="med" len="med"/>
+                      <a:tailEnd type="none" w="med" len="med"/>
+                    </a:lnR>
+                    <a:lnT w="12700" cap="flat" cmpd="sng" algn="ctr">
+                      <a:solidFill>
+                        <a:srgbClr val="DCE4F0"/>
+                      </a:solidFill>
+                      <a:prstDash val="solid"/>
+                      <a:round/>
+                      <a:headEnd type="none" w="med" len="med"/>
+                      <a:tailEnd type="none" w="med" len="med"/>
+                    </a:lnT>
+                    <a:lnB w="12700" cap="flat" cmpd="sng" algn="ctr">
+                      <a:solidFill>
+                        <a:srgbClr val="DCE4F0"/>
+                      </a:solidFill>
+                      <a:prstDash val="solid"/>
+                      <a:round/>
+                      <a:headEnd type="none" w="med" len="med"/>
+                      <a:tailEnd type="none" w="med" len="med"/>
+                    </a:lnB>
+                    <a:solidFill>
+                      <a:srgbClr val="FDF0DC"/>
+                    </a:solidFill>
+                  </a:tcPr>
+                </a:tc>
+                <a:tc>
+                  <a:txBody>
+                    <a:bodyPr/>
+                    <a:lstStyle/>
+                    <a:p>
+                      <a:pPr indent="0" marL="0">
+                        <a:buNone/>
+                      </a:pPr>
+                      <a:r>
+                        <a:rPr lang="en-US" sz="1050" b="1" dirty="0">
+                          <a:solidFill>
+                            <a:srgbClr val="232833"/>
+                          </a:solidFill>
+                          <a:latin typeface="Calibri" pitchFamily="34" charset="0"/>
+                          <a:ea typeface="Calibri" pitchFamily="34" charset="-122"/>
+                          <a:cs typeface="Calibri" pitchFamily="34" charset="-120"/>
+                        </a:rPr>
+                        <a:t>27.0 ± 0.1  (3 seeds)   −37% vs best classical</a:t>
+                      </a:r>
+                      <a:endParaRPr lang="en-US" sz="1050" dirty="0">
+                        <a:latin typeface="Calibri" charset="0"/>
+                        <a:ea typeface="Calibri" charset="0"/>
+                        <a:cs typeface="Calibri" charset="0"/>
+                      </a:endParaRPr>
+                    </a:p>
+                  </a:txBody>
+                  <a:tcPr marL="45720" marR="45720" marT="45720" marB="45720" anchor="ctr">
+                    <a:lnL w="12700" cap="flat" cmpd="sng" algn="ctr">
+                      <a:solidFill>
+                        <a:srgbClr val="DCE4F0"/>
+                      </a:solidFill>
+                      <a:prstDash val="solid"/>
+                      <a:round/>
+                      <a:headEnd type="none" w="med" len="med"/>
+                      <a:tailEnd type="none" w="med" len="med"/>
+                    </a:lnL>
+                    <a:lnR w="12700" cap="flat" cmpd="sng" algn="ctr">
+                      <a:solidFill>
+                        <a:srgbClr val="DCE4F0"/>
+                      </a:solidFill>
+                      <a:prstDash val="solid"/>
+                      <a:round/>
+                      <a:headEnd type="none" w="med" len="med"/>
+                      <a:tailEnd type="none" w="med" len="med"/>
+                    </a:lnR>
+                    <a:lnT w="12700" cap="flat" cmpd="sng" algn="ctr">
+                      <a:solidFill>
+                        <a:srgbClr val="DCE4F0"/>
+                      </a:solidFill>
+                      <a:prstDash val="solid"/>
+                      <a:round/>
+                      <a:headEnd type="none" w="med" len="med"/>
+                      <a:tailEnd type="none" w="med" len="med"/>
+                    </a:lnT>
+                    <a:lnB w="12700" cap="flat" cmpd="sng" algn="ctr">
+                      <a:solidFill>
+                        <a:srgbClr val="DCE4F0"/>
+                      </a:solidFill>
+                      <a:prstDash val="solid"/>
+                      <a:round/>
+                      <a:headEnd type="none" w="med" len="med"/>
+                      <a:tailEnd type="none" w="med" len="med"/>
+                    </a:lnB>
+                    <a:solidFill>
+                      <a:srgbClr val="FDF0DC"/>
+                    </a:solidFill>
+                  </a:tcPr>
+                </a:tc>
+              </a:tr>
+            </a:tbl>
+          </a:graphicData>
+        </a:graphic>
+      </p:graphicFrame>
+      <p:sp>
+        <p:nvSpPr>
+          <p:cNvPr id="6" name="Text 3"/>
+          <p:cNvSpPr/>
+          <p:nvPr/>
+        </p:nvSpPr>
+        <p:spPr>
+          <a:xfrm>
+            <a:off x="502920" y="5806440"/>
+            <a:ext cx="5806440" cy="640080"/>
+          </a:xfrm>
+          <a:prstGeom prst="rect">
+            <a:avLst/>
+          </a:prstGeom>
+          <a:noFill/>
+          <a:ln/>
+        </p:spPr>
+        <p:txBody>
+          <a:bodyPr wrap="square" lIns="0" tIns="0" rIns="0" bIns="0" rtlCol="0" anchor="ctr"/>
+          <a:lstStyle/>
+          <a:p>
+            <a:pPr indent="0" marL="0">
+              <a:lnSpc>
+                <a:spcPct val="105000"/>
+              </a:lnSpc>
+              <a:buNone/>
+            </a:pPr>
+            <a:r>
+              <a:rPr lang="en-US" sz="1150" i="1" dirty="0">
+                <a:solidFill>
+                  <a:srgbClr val="667085"/>
+                </a:solidFill>
+                <a:latin typeface="Calibri" pitchFamily="34" charset="0"/>
+                <a:ea typeface="Calibri" pitchFamily="34" charset="-122"/>
+                <a:cs typeface="Calibri" pitchFamily="34" charset="-120"/>
+              </a:rPr>
+              <a:t>Improvement is uniform over the full MET range; the cell-sum baseline degrades steeply once true MET is large.</a:t>
+            </a:r>
+            <a:endParaRPr lang="en-US" sz="1150" dirty="0"/>
+          </a:p>
+        </p:txBody>
+      </p:sp>
+      <p:pic>
+        <p:nvPicPr>
+          <p:cNvPr id="7" name="Image 0" descr="/private/tmp/claude-503/-Users-afarbin-CaloGNN-CaloGraphNet/641347a1-f97c-4347-b083-6ec9af739b1e/scratchpad/t34/T3B_resolution_vs_met.png">    </p:cNvPr>
+          <p:cNvPicPr>
+            <a:picLocks noChangeAspect="1"/>
+          </p:cNvPicPr>
+          <p:nvPr/>
+        </p:nvPicPr>
+        <p:blipFill>
+          <a:blip r:embed="rId1"/>
+          <a:stretch>
+            <a:fillRect/>
+          </a:stretch>
+        </p:blipFill>
+        <p:spPr>
+          <a:xfrm>
+            <a:off x="6675120" y="1325880"/>
+            <a:ext cx="4846320" cy="3634740"/>
+          </a:xfrm>
+          <a:prstGeom prst="rect">
+            <a:avLst/>
+          </a:prstGeom>
+        </p:spPr>
+      </p:pic>
+      <p:sp>
+        <p:nvSpPr>
+          <p:cNvPr id="8" name="Text 4"/>
+          <p:cNvSpPr/>
+          <p:nvPr/>
+        </p:nvSpPr>
+        <p:spPr>
+          <a:xfrm>
+            <a:off x="6675120" y="5029200"/>
+            <a:ext cx="4937760" cy="292608"/>
+          </a:xfrm>
+          <a:prstGeom prst="rect">
+            <a:avLst/>
+          </a:prstGeom>
+          <a:noFill/>
+          <a:ln/>
+        </p:spPr>
+        <p:txBody>
+          <a:bodyPr wrap="square" lIns="0" tIns="0" rIns="0" bIns="0" rtlCol="0" anchor="ctr"/>
+          <a:lstStyle/>
+          <a:p>
+            <a:pPr indent="0" marL="0">
+              <a:buNone/>
+            </a:pPr>
+            <a:r>
+              <a:rPr lang="en-US" sz="1000" i="1" dirty="0">
+                <a:solidFill>
+                  <a:srgbClr val="667085"/>
+                </a:solidFill>
+                <a:latin typeface="Calibri" pitchFamily="34" charset="0"/>
+                <a:ea typeface="Calibri" pitchFamily="34" charset="-122"/>
+                <a:cs typeface="Calibri" pitchFamily="34" charset="-120"/>
+              </a:rPr>
+              <a:t>Resolution vs true |MET|: learned estimate vs classical vector sums, identical test events.</a:t>
+            </a:r>
+            <a:endParaRPr lang="en-US" sz="1000" dirty="0"/>
+          </a:p>
+        </p:txBody>
+      </p:sp>
+      <p:sp>
+        <p:nvSpPr>
+          <p:cNvPr id="9" name="Text 5"/>
+          <p:cNvSpPr/>
+          <p:nvPr/>
+        </p:nvSpPr>
+        <p:spPr>
+          <a:xfrm>
+            <a:off x="502920" y="6510528"/>
+            <a:ext cx="4114800" cy="274320"/>
+          </a:xfrm>
+          <a:prstGeom prst="rect">
+            <a:avLst/>
+          </a:prstGeom>
+          <a:noFill/>
+          <a:ln/>
+        </p:spPr>
+        <p:txBody>
+          <a:bodyPr wrap="square" lIns="0" tIns="0" rIns="0" bIns="0" rtlCol="0" anchor="ctr"/>
+          <a:lstStyle/>
+          <a:p>
+            <a:pPr indent="0" marL="0">
+              <a:buNone/>
+            </a:pPr>
+            <a:r>
+              <a:rPr lang="en-US" sz="900" dirty="0">
+                <a:solidFill>
+                  <a:srgbClr val="667085"/>
+                </a:solidFill>
+                <a:latin typeface="Calibri" pitchFamily="34" charset="0"/>
+                <a:ea typeface="Calibri" pitchFamily="34" charset="-122"/>
+                <a:cs typeface="Calibri" pitchFamily="34" charset="-120"/>
+              </a:rPr>
+              <a:t>DFM feasibility — UT Arlington · Aug 2026</a:t>
+            </a:r>
+            <a:endParaRPr lang="en-US" sz="900" dirty="0"/>
+          </a:p>
+        </p:txBody>
+      </p:sp>
+      <p:sp>
+        <p:nvSpPr>
+          <p:cNvPr id="10" name="Text 6"/>
+          <p:cNvSpPr/>
+          <p:nvPr/>
+        </p:nvSpPr>
+        <p:spPr>
+          <a:xfrm>
+            <a:off x="11430000" y="6510528"/>
+            <a:ext cx="365760" cy="274320"/>
+          </a:xfrm>
+          <a:prstGeom prst="rect">
+            <a:avLst/>
+          </a:prstGeom>
+          <a:noFill/>
+          <a:ln/>
+        </p:spPr>
+        <p:txBody>
+          <a:bodyPr wrap="square" lIns="0" tIns="0" rIns="0" bIns="0" rtlCol="0" anchor="ctr"/>
+          <a:lstStyle/>
+          <a:p>
+            <a:pPr algn="r" indent="0" marL="0">
+              <a:buNone/>
+            </a:pPr>
+            <a:r>
+              <a:rPr lang="en-US" sz="900" dirty="0">
+                <a:solidFill>
+                  <a:srgbClr val="667085"/>
+                </a:solidFill>
+                <a:latin typeface="Calibri" pitchFamily="34" charset="0"/>
+                <a:ea typeface="Calibri" pitchFamily="34" charset="-122"/>
+                <a:cs typeface="Calibri" pitchFamily="34" charset="-120"/>
+              </a:rPr>
+              <a:t>15</a:t>
+            </a:r>
+            <a:endParaRPr lang="en-US" sz="900" dirty="0"/>
+          </a:p>
+        </p:txBody>
+      </p:sp>
+    </p:spTree>
+  </p:cSld>
+  <p:clrMapOvr>
+    <a:masterClrMapping/>
+  </p:clrMapOvr>
+</p:sld>
+</file>
+
+<file path=ppt/slides/slide16.xml><?xml version="1.0" encoding="utf-8"?>
+<p:sld xmlns:a="http://schemas.openxmlformats.org/drawingml/2006/main" xmlns:r="http://schemas.openxmlformats.org/officeDocument/2006/relationships" xmlns:p="http://schemas.openxmlformats.org/presentationml/2006/main">
+  <p:cSld name="Slide 16">
+    <p:spTree>
+      <p:nvGrpSpPr>
+        <p:cNvPr id="1" name=""/>
+        <p:cNvGrpSpPr/>
+        <p:nvPr/>
+      </p:nvGrpSpPr>
+      <p:grpSpPr>
+        <a:xfrm>
+          <a:off x="0" y="0"/>
+          <a:ext cx="0" cy="0"/>
+          <a:chOff x="0" y="0"/>
+          <a:chExt cx="0" cy="0"/>
+        </a:xfrm>
+      </p:grpSpPr>
+      <p:sp>
+        <p:nvSpPr>
+          <p:cNvPr id="2" name="Text 0"/>
+          <p:cNvSpPr/>
+          <p:nvPr/>
+        </p:nvSpPr>
+        <p:spPr>
+          <a:xfrm>
+            <a:off x="502920" y="256032"/>
+            <a:ext cx="11155680" cy="274320"/>
+          </a:xfrm>
+          <a:prstGeom prst="rect">
+            <a:avLst/>
+          </a:prstGeom>
+          <a:noFill/>
+          <a:ln/>
+        </p:spPr>
+        <p:txBody>
+          <a:bodyPr wrap="square" lIns="0" tIns="0" rIns="0" bIns="0" rtlCol="0" anchor="ctr"/>
+          <a:lstStyle/>
+          <a:p>
+            <a:pPr indent="0" marL="0">
+              <a:buNone/>
+            </a:pPr>
+            <a:r>
+              <a:rPr lang="en-US" sz="1050" b="1" spc="200" kern="0" dirty="0">
+                <a:solidFill>
+                  <a:srgbClr val="667085"/>
+                </a:solidFill>
+                <a:latin typeface="Calibri" pitchFamily="34" charset="0"/>
+                <a:ea typeface="Calibri" pitchFamily="34" charset="-122"/>
+                <a:cs typeface="Calibri" pitchFamily="34" charset="-120"/>
+              </a:rPr>
+              <a:t>BACKUP — EVENT-LEVEL TASKS</a:t>
+            </a:r>
+            <a:endParaRPr lang="en-US" sz="1050" dirty="0"/>
+          </a:p>
+        </p:txBody>
+      </p:sp>
+      <p:sp>
+        <p:nvSpPr>
+          <p:cNvPr id="3" name="Text 1"/>
+          <p:cNvSpPr/>
+          <p:nvPr/>
+        </p:nvSpPr>
+        <p:spPr>
+          <a:xfrm>
+            <a:off x="502920" y="475488"/>
+            <a:ext cx="11155680" cy="566928"/>
+          </a:xfrm>
+          <a:prstGeom prst="rect">
+            <a:avLst/>
+          </a:prstGeom>
+          <a:noFill/>
+          <a:ln/>
+        </p:spPr>
+        <p:txBody>
+          <a:bodyPr wrap="square" lIns="0" tIns="0" rIns="0" bIns="0" rtlCol="0" anchor="ctr"/>
+          <a:lstStyle/>
+          <a:p>
+            <a:pPr indent="0" marL="0">
+              <a:buNone/>
+            </a:pPr>
+            <a:r>
+              <a:rPr lang="en-US" sz="2700" b="1" dirty="0">
+                <a:solidFill>
+                  <a:srgbClr val="1E2761"/>
+                </a:solidFill>
+                <a:latin typeface="Calibri" pitchFamily="34" charset="0"/>
+                <a:ea typeface="Calibri" pitchFamily="34" charset="-122"/>
+                <a:cs typeface="Calibri" pitchFamily="34" charset="-120"/>
+              </a:rPr>
+              <a:t>T3: where the MET information lives</a:t>
+            </a:r>
+            <a:endParaRPr lang="en-US" sz="2700" dirty="0"/>
+          </a:p>
+        </p:txBody>
+      </p:sp>
+      <p:pic>
+        <p:nvPicPr>
+          <p:cNvPr id="4" name="Image 0" descr="/private/tmp/claude-503/-Users-afarbin-CaloGNN-CaloGraphNet/641347a1-f97c-4347-b083-6ec9af739b1e/scratchpad/t34/T3C_correlation.png">    </p:cNvPr>
+          <p:cNvPicPr>
+            <a:picLocks noChangeAspect="1"/>
+          </p:cNvPicPr>
+          <p:nvPr/>
+        </p:nvPicPr>
+        <p:blipFill>
+          <a:blip r:embed="rId1"/>
+          <a:stretch>
+            <a:fillRect/>
+          </a:stretch>
+        </p:blipFill>
+        <p:spPr>
+          <a:xfrm>
+            <a:off x="1920240" y="1234440"/>
+            <a:ext cx="8321040" cy="3870251"/>
+          </a:xfrm>
+          <a:prstGeom prst="rect">
+            <a:avLst/>
+          </a:prstGeom>
+        </p:spPr>
+      </p:pic>
+      <p:sp>
+        <p:nvSpPr>
+          <p:cNvPr id="5" name="Text 2"/>
+          <p:cNvSpPr/>
+          <p:nvPr/>
+        </p:nvSpPr>
+        <p:spPr>
+          <a:xfrm>
+            <a:off x="1920240" y="5257800"/>
+            <a:ext cx="8321040" cy="292608"/>
+          </a:xfrm>
+          <a:prstGeom prst="rect">
+            <a:avLst/>
+          </a:prstGeom>
+          <a:noFill/>
+          <a:ln/>
+        </p:spPr>
+        <p:txBody>
+          <a:bodyPr wrap="square" lIns="0" tIns="0" rIns="0" bIns="0" rtlCol="0" anchor="ctr"/>
+          <a:lstStyle/>
+          <a:p>
+            <a:pPr indent="0" marL="0">
+              <a:buNone/>
+            </a:pPr>
+            <a:r>
+              <a:rPr lang="en-US" sz="1000" i="1" dirty="0">
+                <a:solidFill>
+                  <a:srgbClr val="667085"/>
+                </a:solidFill>
+                <a:latin typeface="Calibri" pitchFamily="34" charset="0"/>
+                <a:ea typeface="Calibri" pitchFamily="34" charset="-122"/>
+                <a:cs typeface="Calibri" pitchFamily="34" charset="-120"/>
+              </a:rPr>
+              <a:t>Predicted vs true |MET|, test events: the same encoder with cells (left) and without (right).</a:t>
+            </a:r>
+            <a:endParaRPr lang="en-US" sz="1000" dirty="0"/>
+          </a:p>
+        </p:txBody>
+      </p:sp>
+      <p:sp>
+        <p:nvSpPr>
+          <p:cNvPr id="6" name="Text 3"/>
+          <p:cNvSpPr/>
+          <p:nvPr/>
+        </p:nvSpPr>
+        <p:spPr>
+          <a:xfrm>
+            <a:off x="822960" y="5669280"/>
+            <a:ext cx="10515600" cy="1051560"/>
+          </a:xfrm>
+          <a:prstGeom prst="rect">
+            <a:avLst/>
+          </a:prstGeom>
+          <a:noFill/>
+          <a:ln/>
+        </p:spPr>
+        <p:txBody>
+          <a:bodyPr wrap="square" lIns="0" tIns="0" rIns="0" bIns="0" rtlCol="0" anchor="t"/>
+          <a:lstStyle/>
+          <a:p>
+            <a:pPr marL="127000" indent="-127000">
+              <a:lnSpc>
+                <a:spcPct val="107000"/>
+              </a:lnSpc>
+              <a:buSzPct val="100000"/>
+              <a:buChar char="•"/>
+            </a:pPr>
+            <a:r>
+              <a:rPr lang="en-US" sz="1150" b="1" dirty="0">
+                <a:solidFill>
+                  <a:srgbClr val="1E2761"/>
+                </a:solidFill>
+                <a:latin typeface="Calibri" pitchFamily="34" charset="0"/>
+                <a:ea typeface="Calibri" pitchFamily="34" charset="-122"/>
+                <a:cs typeface="Calibri" pitchFamily="34" charset="-120"/>
+              </a:rPr>
+              <a:t>Tracks alone collapse:</a:t>
+            </a:r>
+            <a:pPr indent="0" marL="0">
+              <a:lnSpc>
+                <a:spcPct val="107000"/>
+              </a:lnSpc>
+              <a:spcAft>
+                <a:spcPts val="600"/>
+              </a:spcAft>
+              <a:buNone/>
+            </a:pPr>
+            <a:r>
+              <a:rPr lang="en-US" sz="1150" dirty="0">
+                <a:solidFill>
+                  <a:srgbClr val="232833"/>
+                </a:solidFill>
+                <a:latin typeface="Calibri" pitchFamily="34" charset="0"/>
+                <a:ea typeface="Calibri" pitchFamily="34" charset="-122"/>
+                <a:cs typeface="Calibri" pitchFamily="34" charset="-120"/>
+              </a:rPr>
+              <a:t> every seed converges to a near-constant output (prediction spread ≈ 0, correlation ≈ 0) — charged recoil carries almost no extractable neutrino information at this scale, and the optimizer finds the trivial minimum.</a:t>
+            </a:r>
+            <a:endParaRPr lang="en-US" sz="1150" dirty="0"/>
+          </a:p>
+          <a:p>
+            <a:pPr marL="127000" indent="-127000">
+              <a:lnSpc>
+                <a:spcPct val="107000"/>
+              </a:lnSpc>
+              <a:buSzPct val="100000"/>
+              <a:buChar char="•"/>
+            </a:pPr>
+            <a:r>
+              <a:rPr lang="en-US" sz="1150" b="1" dirty="0">
+                <a:solidFill>
+                  <a:srgbClr val="1E2761"/>
+                </a:solidFill>
+                <a:latin typeface="Calibri" pitchFamily="34" charset="0"/>
+                <a:ea typeface="Calibri" pitchFamily="34" charset="-122"/>
+                <a:cs typeface="Calibri" pitchFamily="34" charset="-120"/>
+              </a:rPr>
+              <a:t>Cells flip the outcome:</a:t>
+            </a:r>
+            <a:pPr indent="0" marL="0">
+              <a:lnSpc>
+                <a:spcPct val="107000"/>
+              </a:lnSpc>
+              <a:spcAft>
+                <a:spcPts val="600"/>
+              </a:spcAft>
+              <a:buNone/>
+            </a:pPr>
+            <a:r>
+              <a:rPr lang="en-US" sz="1150" dirty="0">
+                <a:solidFill>
+                  <a:srgbClr val="232833"/>
+                </a:solidFill>
+                <a:latin typeface="Calibri" pitchFamily="34" charset="0"/>
+                <a:ea typeface="Calibri" pitchFamily="34" charset="-122"/>
+                <a:cs typeface="Calibri" pitchFamily="34" charset="-120"/>
+              </a:rPr>
+              <a:t> the identical encoder, given the matched cells and their transferred neighbor graph, correlates strongly with truth — MET is a calorimeter measurement, and the event-level graph the cell-matching bridge enables is doing real work.</a:t>
+            </a:r>
+            <a:endParaRPr lang="en-US" sz="1150" dirty="0"/>
+          </a:p>
+        </p:txBody>
+      </p:sp>
+      <p:sp>
+        <p:nvSpPr>
+          <p:cNvPr id="7" name="Text 4"/>
+          <p:cNvSpPr/>
+          <p:nvPr/>
+        </p:nvSpPr>
+        <p:spPr>
+          <a:xfrm>
+            <a:off x="502920" y="6510528"/>
+            <a:ext cx="4114800" cy="274320"/>
+          </a:xfrm>
+          <a:prstGeom prst="rect">
+            <a:avLst/>
+          </a:prstGeom>
+          <a:noFill/>
+          <a:ln/>
+        </p:spPr>
+        <p:txBody>
+          <a:bodyPr wrap="square" lIns="0" tIns="0" rIns="0" bIns="0" rtlCol="0" anchor="ctr"/>
+          <a:lstStyle/>
+          <a:p>
+            <a:pPr indent="0" marL="0">
+              <a:buNone/>
+            </a:pPr>
+            <a:r>
+              <a:rPr lang="en-US" sz="900" dirty="0">
+                <a:solidFill>
+                  <a:srgbClr val="667085"/>
+                </a:solidFill>
+                <a:latin typeface="Calibri" pitchFamily="34" charset="0"/>
+                <a:ea typeface="Calibri" pitchFamily="34" charset="-122"/>
+                <a:cs typeface="Calibri" pitchFamily="34" charset="-120"/>
+              </a:rPr>
+              <a:t>DFM feasibility — UT Arlington · Aug 2026</a:t>
+            </a:r>
+            <a:endParaRPr lang="en-US" sz="900" dirty="0"/>
+          </a:p>
+        </p:txBody>
+      </p:sp>
+      <p:sp>
+        <p:nvSpPr>
+          <p:cNvPr id="8" name="Text 5"/>
+          <p:cNvSpPr/>
+          <p:nvPr/>
+        </p:nvSpPr>
+        <p:spPr>
+          <a:xfrm>
+            <a:off x="11430000" y="6510528"/>
+            <a:ext cx="365760" cy="274320"/>
+          </a:xfrm>
+          <a:prstGeom prst="rect">
+            <a:avLst/>
+          </a:prstGeom>
+          <a:noFill/>
+          <a:ln/>
+        </p:spPr>
+        <p:txBody>
+          <a:bodyPr wrap="square" lIns="0" tIns="0" rIns="0" bIns="0" rtlCol="0" anchor="ctr"/>
+          <a:lstStyle/>
+          <a:p>
+            <a:pPr algn="r" indent="0" marL="0">
+              <a:buNone/>
+            </a:pPr>
+            <a:r>
+              <a:rPr lang="en-US" sz="900" dirty="0">
+                <a:solidFill>
+                  <a:srgbClr val="667085"/>
+                </a:solidFill>
+                <a:latin typeface="Calibri" pitchFamily="34" charset="0"/>
+                <a:ea typeface="Calibri" pitchFamily="34" charset="-122"/>
+                <a:cs typeface="Calibri" pitchFamily="34" charset="-120"/>
+              </a:rPr>
+              <a:t>16</a:t>
+            </a:r>
+            <a:endParaRPr lang="en-US" sz="900" dirty="0"/>
+          </a:p>
+        </p:txBody>
+      </p:sp>
+    </p:spTree>
+  </p:cSld>
+  <p:clrMapOvr>
+    <a:masterClrMapping/>
+  </p:clrMapOvr>
+</p:sld>
+</file>
+
+<file path=ppt/slides/slide17.xml><?xml version="1.0" encoding="utf-8"?>
+<p:sld xmlns:a="http://schemas.openxmlformats.org/drawingml/2006/main" xmlns:r="http://schemas.openxmlformats.org/officeDocument/2006/relationships" xmlns:p="http://schemas.openxmlformats.org/presentationml/2006/main">
+  <p:cSld name="Slide 17">
+    <p:spTree>
+      <p:nvGrpSpPr>
+        <p:cNvPr id="1" name=""/>
+        <p:cNvGrpSpPr/>
+        <p:nvPr/>
+      </p:nvGrpSpPr>
+      <p:grpSpPr>
+        <a:xfrm>
+          <a:off x="0" y="0"/>
+          <a:ext cx="0" cy="0"/>
+          <a:chOff x="0" y="0"/>
+          <a:chExt cx="0" cy="0"/>
+        </a:xfrm>
+      </p:grpSpPr>
+      <p:sp>
+        <p:nvSpPr>
+          <p:cNvPr id="2" name="Text 0"/>
+          <p:cNvSpPr/>
+          <p:nvPr/>
+        </p:nvSpPr>
+        <p:spPr>
+          <a:xfrm>
+            <a:off x="502920" y="256032"/>
+            <a:ext cx="11155680" cy="274320"/>
+          </a:xfrm>
+          <a:prstGeom prst="rect">
+            <a:avLst/>
+          </a:prstGeom>
+          <a:noFill/>
+          <a:ln/>
+        </p:spPr>
+        <p:txBody>
+          <a:bodyPr wrap="square" lIns="0" tIns="0" rIns="0" bIns="0" rtlCol="0" anchor="ctr"/>
+          <a:lstStyle/>
+          <a:p>
+            <a:pPr indent="0" marL="0">
+              <a:buNone/>
+            </a:pPr>
+            <a:r>
+              <a:rPr lang="en-US" sz="1050" b="1" spc="200" kern="0" dirty="0">
+                <a:solidFill>
+                  <a:srgbClr val="667085"/>
+                </a:solidFill>
+                <a:latin typeface="Calibri" pitchFamily="34" charset="0"/>
+                <a:ea typeface="Calibri" pitchFamily="34" charset="-122"/>
+                <a:cs typeface="Calibri" pitchFamily="34" charset="-120"/>
+              </a:rPr>
+              <a:t>BACKUP — EVENT-LEVEL TASKS</a:t>
+            </a:r>
+            <a:endParaRPr lang="en-US" sz="1050" dirty="0"/>
+          </a:p>
+        </p:txBody>
+      </p:sp>
+      <p:sp>
+        <p:nvSpPr>
+          <p:cNvPr id="3" name="Text 1"/>
+          <p:cNvSpPr/>
+          <p:nvPr/>
+        </p:nvSpPr>
+        <p:spPr>
+          <a:xfrm>
+            <a:off x="502920" y="475488"/>
+            <a:ext cx="11155680" cy="566928"/>
+          </a:xfrm>
+          <a:prstGeom prst="rect">
+            <a:avLst/>
+          </a:prstGeom>
+          <a:noFill/>
+          <a:ln/>
+        </p:spPr>
+        <p:txBody>
+          <a:bodyPr wrap="square" lIns="0" tIns="0" rIns="0" bIns="0" rtlCol="0" anchor="ctr"/>
+          <a:lstStyle/>
+          <a:p>
+            <a:pPr indent="0" marL="0">
+              <a:buNone/>
+            </a:pPr>
+            <a:r>
+              <a:rPr lang="en-US" sz="2700" b="1" dirty="0">
+                <a:solidFill>
+                  <a:srgbClr val="1E2761"/>
+                </a:solidFill>
+                <a:latin typeface="Calibri" pitchFamily="34" charset="0"/>
+                <a:ea typeface="Calibri" pitchFamily="34" charset="-122"/>
+                <a:cs typeface="Calibri" pitchFamily="34" charset="-120"/>
+              </a:rPr>
+              <a:t>T4: one-shot jet finding via set prediction</a:t>
+            </a:r>
+            <a:endParaRPr lang="en-US" sz="2700" dirty="0"/>
+          </a:p>
+        </p:txBody>
+      </p:sp>
+      <p:sp>
+        <p:nvSpPr>
+          <p:cNvPr id="4" name="Text 2"/>
+          <p:cNvSpPr/>
+          <p:nvPr/>
+        </p:nvSpPr>
+        <p:spPr>
+          <a:xfrm>
+            <a:off x="502920" y="1234440"/>
+            <a:ext cx="5943600" cy="1234440"/>
+          </a:xfrm>
+          <a:prstGeom prst="rect">
+            <a:avLst/>
+          </a:prstGeom>
+          <a:noFill/>
+          <a:ln/>
+        </p:spPr>
+        <p:txBody>
+          <a:bodyPr wrap="square" lIns="0" tIns="0" rIns="0" bIns="0" rtlCol="0" anchor="t"/>
+          <a:lstStyle/>
+          <a:p>
+            <a:pPr marL="127000" indent="-127000">
+              <a:lnSpc>
+                <a:spcPct val="107000"/>
+              </a:lnSpc>
+              <a:buSzPct val="100000"/>
+              <a:buChar char="•"/>
+            </a:pPr>
+            <a:r>
+              <a:rPr lang="en-US" sz="1200" b="1" dirty="0">
+                <a:solidFill>
+                  <a:srgbClr val="1E2761"/>
+                </a:solidFill>
+                <a:latin typeface="Calibri" pitchFamily="34" charset="0"/>
+                <a:ea typeface="Calibri" pitchFamily="34" charset="-122"/>
+                <a:cs typeface="Calibri" pitchFamily="34" charset="-120"/>
+              </a:rPr>
+              <a:t>Method (DETR-style):</a:t>
+            </a:r>
+            <a:pPr indent="0" marL="0">
+              <a:lnSpc>
+                <a:spcPct val="107000"/>
+              </a:lnSpc>
+              <a:spcAft>
+                <a:spcPts val="600"/>
+              </a:spcAft>
+              <a:buNone/>
+            </a:pPr>
+            <a:r>
+              <a:rPr lang="en-US" sz="1200" dirty="0">
+                <a:solidFill>
+                  <a:srgbClr val="232833"/>
+                </a:solidFill>
+                <a:latin typeface="Calibri" pitchFamily="34" charset="0"/>
+                <a:ea typeface="Calibri" pitchFamily="34" charset="-122"/>
+                <a:cs typeface="Calibri" pitchFamily="34" charset="-120"/>
+              </a:rPr>
+              <a:t> 12 learned queries cross-attend to the event tokens; per query (existence, log pT, η, φ). Hungarian-matched set loss: existence BCE + kinematic L1 on matched pairs. Truth: hard-scatter jets, pT &gt; 20 GeV.</a:t>
+            </a:r>
+            <a:endParaRPr lang="en-US" sz="1200" dirty="0"/>
+          </a:p>
+        </p:txBody>
+      </p:sp>
+      <p:graphicFrame>
+        <p:nvGraphicFramePr>
+          <p:cNvPr id="18" name="Table 0"/>
+          <p:cNvGraphicFramePr>
+            <a:graphicFrameLocks noGrp="1"/>
+          </p:cNvGraphicFramePr>
+          <p:nvPr>
+            <p:extLst>
+              <p:ext uri="{D42A27DB-BD31-4B8C-83A1-F6EECF244321}">
+                <p14:modId xmlns:p14="http://schemas.microsoft.com/office/powerpoint/2010/main" val="1579011935"/>
+              </p:ext>
+            </p:extLst>
+          </p:nvPr>
+        </p:nvGraphicFramePr>
+        <p:xfrm>
+          <a:off x="502920" y="2560320"/>
+          <a:ext cx="5943600" cy="914400"/>
+        </p:xfrm>
+        <a:graphic>
+          <a:graphicData uri="http://schemas.openxmlformats.org/drawingml/2006/table">
+            <a:tbl>
+              <a:tblPr/>
+              <a:tblGrid>
+                <a:gridCol w="2468880"/>
+                <a:gridCol w="1737360"/>
+                <a:gridCol w="1737360"/>
+              </a:tblGrid>
+              <a:tr h="329184">
+                <a:tc>
+                  <a:txBody>
+                    <a:bodyPr/>
+                    <a:lstStyle/>
+                    <a:p>
+                      <a:pPr indent="0" marL="0">
+                        <a:buNone/>
+                      </a:pPr>
+                      <a:r>
+                        <a:rPr lang="en-US" sz="1050" b="1" dirty="0">
+                          <a:solidFill>
+                            <a:srgbClr val="FFFFFF"/>
+                          </a:solidFill>
+                          <a:latin typeface="Calibri" pitchFamily="34" charset="0"/>
+                          <a:ea typeface="Calibri" pitchFamily="34" charset="-122"/>
+                          <a:cs typeface="Calibri" pitchFamily="34" charset="-120"/>
+                        </a:rPr>
+                        <a:t>Metric (3 seeds)</a:t>
+                      </a:r>
+                      <a:endParaRPr lang="en-US" sz="1050" dirty="0">
+                        <a:latin typeface="Calibri" charset="0"/>
+                        <a:ea typeface="Calibri" charset="0"/>
+                        <a:cs typeface="Calibri" charset="0"/>
+                      </a:endParaRPr>
+                    </a:p>
+                  </a:txBody>
+                  <a:tcPr marL="45720" marR="45720" marT="45720" marB="45720" anchor="ctr">
+                    <a:lnL w="12700" cap="flat" cmpd="sng" algn="ctr">
+                      <a:solidFill>
+                        <a:srgbClr val="DCE4F0"/>
+                      </a:solidFill>
+                      <a:prstDash val="solid"/>
+                      <a:round/>
+                      <a:headEnd type="none" w="med" len="med"/>
+                      <a:tailEnd type="none" w="med" len="med"/>
+                    </a:lnL>
+                    <a:lnR w="12700" cap="flat" cmpd="sng" algn="ctr">
+                      <a:solidFill>
+                        <a:srgbClr val="DCE4F0"/>
+                      </a:solidFill>
+                      <a:prstDash val="solid"/>
+                      <a:round/>
+                      <a:headEnd type="none" w="med" len="med"/>
+                      <a:tailEnd type="none" w="med" len="med"/>
+                    </a:lnR>
+                    <a:lnT w="12700" cap="flat" cmpd="sng" algn="ctr">
+                      <a:solidFill>
+                        <a:srgbClr val="DCE4F0"/>
+                      </a:solidFill>
+                      <a:prstDash val="solid"/>
+                      <a:round/>
+                      <a:headEnd type="none" w="med" len="med"/>
+                      <a:tailEnd type="none" w="med" len="med"/>
+                    </a:lnT>
+                    <a:lnB w="12700" cap="flat" cmpd="sng" algn="ctr">
+                      <a:solidFill>
+                        <a:srgbClr val="DCE4F0"/>
+                      </a:solidFill>
+                      <a:prstDash val="solid"/>
+                      <a:round/>
+                      <a:headEnd type="none" w="med" len="med"/>
+                      <a:tailEnd type="none" w="med" len="med"/>
+                    </a:lnB>
+                    <a:solidFill>
+                      <a:srgbClr val="1E2761"/>
+                    </a:solidFill>
+                  </a:tcPr>
+                </a:tc>
+                <a:tc>
+                  <a:txBody>
+                    <a:bodyPr/>
+                    <a:lstStyle/>
+                    <a:p>
+                      <a:pPr indent="0" marL="0">
+                        <a:buNone/>
+                      </a:pPr>
+                      <a:r>
+                        <a:rPr lang="en-US" sz="1050" b="1" dirty="0">
+                          <a:solidFill>
+                            <a:srgbClr val="FFFFFF"/>
+                          </a:solidFill>
+                          <a:latin typeface="Calibri" pitchFamily="34" charset="0"/>
+                          <a:ea typeface="Calibri" pitchFamily="34" charset="-122"/>
+                          <a:cs typeface="Calibri" pitchFamily="34" charset="-120"/>
+                        </a:rPr>
+                        <a:t>tracks</a:t>
+                      </a:r>
+                      <a:endParaRPr lang="en-US" sz="1050" dirty="0">
+                        <a:latin typeface="Calibri" charset="0"/>
+                        <a:ea typeface="Calibri" charset="0"/>
+                        <a:cs typeface="Calibri" charset="0"/>
+                      </a:endParaRPr>
+                    </a:p>
+                  </a:txBody>
+                  <a:tcPr marL="45720" marR="45720" marT="45720" marB="45720" anchor="ctr">
+                    <a:lnL w="12700" cap="flat" cmpd="sng" algn="ctr">
+                      <a:solidFill>
+                        <a:srgbClr val="DCE4F0"/>
+                      </a:solidFill>
+                      <a:prstDash val="solid"/>
+                      <a:round/>
+                      <a:headEnd type="none" w="med" len="med"/>
+                      <a:tailEnd type="none" w="med" len="med"/>
+                    </a:lnL>
+                    <a:lnR w="12700" cap="flat" cmpd="sng" algn="ctr">
+                      <a:solidFill>
+                        <a:srgbClr val="DCE4F0"/>
+                      </a:solidFill>
+                      <a:prstDash val="solid"/>
+                      <a:round/>
+                      <a:headEnd type="none" w="med" len="med"/>
+                      <a:tailEnd type="none" w="med" len="med"/>
+                    </a:lnR>
+                    <a:lnT w="12700" cap="flat" cmpd="sng" algn="ctr">
+                      <a:solidFill>
+                        <a:srgbClr val="DCE4F0"/>
+                      </a:solidFill>
+                      <a:prstDash val="solid"/>
+                      <a:round/>
+                      <a:headEnd type="none" w="med" len="med"/>
+                      <a:tailEnd type="none" w="med" len="med"/>
+                    </a:lnT>
+                    <a:lnB w="12700" cap="flat" cmpd="sng" algn="ctr">
+                      <a:solidFill>
+                        <a:srgbClr val="DCE4F0"/>
+                      </a:solidFill>
+                      <a:prstDash val="solid"/>
+                      <a:round/>
+                      <a:headEnd type="none" w="med" len="med"/>
+                      <a:tailEnd type="none" w="med" len="med"/>
+                    </a:lnB>
+                    <a:solidFill>
+                      <a:srgbClr val="1E2761"/>
+                    </a:solidFill>
+                  </a:tcPr>
+                </a:tc>
+                <a:tc>
+                  <a:txBody>
+                    <a:bodyPr/>
+                    <a:lstStyle/>
+                    <a:p>
+                      <a:pPr indent="0" marL="0">
+                        <a:buNone/>
+                      </a:pPr>
+                      <a:r>
+                        <a:rPr lang="en-US" sz="1050" b="1" dirty="0">
+                          <a:solidFill>
+                            <a:srgbClr val="FFFFFF"/>
+                          </a:solidFill>
+                          <a:latin typeface="Calibri" pitchFamily="34" charset="0"/>
+                          <a:ea typeface="Calibri" pitchFamily="34" charset="-122"/>
+                          <a:cs typeface="Calibri" pitchFamily="34" charset="-120"/>
+                        </a:rPr>
+                        <a:t>tracks + cells</a:t>
+                      </a:r>
+                      <a:endParaRPr lang="en-US" sz="1050" dirty="0">
+                        <a:latin typeface="Calibri" charset="0"/>
+                        <a:ea typeface="Calibri" charset="0"/>
+                        <a:cs typeface="Calibri" charset="0"/>
+                      </a:endParaRPr>
+                    </a:p>
+                  </a:txBody>
+                  <a:tcPr marL="45720" marR="45720" marT="45720" marB="45720" anchor="ctr">
+                    <a:lnL w="12700" cap="flat" cmpd="sng" algn="ctr">
+                      <a:solidFill>
+                        <a:srgbClr val="DCE4F0"/>
+                      </a:solidFill>
+                      <a:prstDash val="solid"/>
+                      <a:round/>
+                      <a:headEnd type="none" w="med" len="med"/>
+                      <a:tailEnd type="none" w="med" len="med"/>
+                    </a:lnL>
+                    <a:lnR w="12700" cap="flat" cmpd="sng" algn="ctr">
+                      <a:solidFill>
+                        <a:srgbClr val="DCE4F0"/>
+                      </a:solidFill>
+                      <a:prstDash val="solid"/>
+                      <a:round/>
+                      <a:headEnd type="none" w="med" len="med"/>
+                      <a:tailEnd type="none" w="med" len="med"/>
+                    </a:lnR>
+                    <a:lnT w="12700" cap="flat" cmpd="sng" algn="ctr">
+                      <a:solidFill>
+                        <a:srgbClr val="DCE4F0"/>
+                      </a:solidFill>
+                      <a:prstDash val="solid"/>
+                      <a:round/>
+                      <a:headEnd type="none" w="med" len="med"/>
+                      <a:tailEnd type="none" w="med" len="med"/>
+                    </a:lnT>
+                    <a:lnB w="12700" cap="flat" cmpd="sng" algn="ctr">
+                      <a:solidFill>
+                        <a:srgbClr val="DCE4F0"/>
+                      </a:solidFill>
+                      <a:prstDash val="solid"/>
+                      <a:round/>
+                      <a:headEnd type="none" w="med" len="med"/>
+                      <a:tailEnd type="none" w="med" len="med"/>
+                    </a:lnB>
+                    <a:solidFill>
+                      <a:srgbClr val="1E2761"/>
+                    </a:solidFill>
+                  </a:tcPr>
+                </a:tc>
+              </a:tr>
+              <a:tr h="329184">
+                <a:tc>
+                  <a:txBody>
+                    <a:bodyPr/>
+                    <a:lstStyle/>
+                    <a:p>
+                      <a:pPr indent="0" marL="0">
+                        <a:buNone/>
+                      </a:pPr>
+                      <a:r>
+                        <a:rPr lang="en-US" sz="1050" dirty="0">
+                          <a:solidFill>
+                            <a:srgbClr val="232833"/>
+                          </a:solidFill>
+                          <a:latin typeface="Calibri" pitchFamily="34" charset="0"/>
+                          <a:ea typeface="Calibri" pitchFamily="34" charset="-122"/>
+                          <a:cs typeface="Calibri" pitchFamily="34" charset="-120"/>
+                        </a:rPr>
+                        <a:t>efficiency (pT &gt; 20)</a:t>
+                      </a:r>
+                      <a:endParaRPr lang="en-US" sz="1050" dirty="0">
+                        <a:latin typeface="Calibri" charset="0"/>
+                        <a:ea typeface="Calibri" charset="0"/>
+                        <a:cs typeface="Calibri" charset="0"/>
+                      </a:endParaRPr>
+                    </a:p>
+                  </a:txBody>
+                  <a:tcPr marL="45720" marR="45720" marT="45720" marB="45720" anchor="ctr">
+                    <a:lnL w="12700" cap="flat" cmpd="sng" algn="ctr">
+                      <a:solidFill>
+                        <a:srgbClr val="DCE4F0"/>
+                      </a:solidFill>
+                      <a:prstDash val="solid"/>
+                      <a:round/>
+                      <a:headEnd type="none" w="med" len="med"/>
+                      <a:tailEnd type="none" w="med" len="med"/>
+                    </a:lnL>
+                    <a:lnR w="12700" cap="flat" cmpd="sng" algn="ctr">
+                      <a:solidFill>
+                        <a:srgbClr val="DCE4F0"/>
+                      </a:solidFill>
+                      <a:prstDash val="solid"/>
+                      <a:round/>
+                      <a:headEnd type="none" w="med" len="med"/>
+                      <a:tailEnd type="none" w="med" len="med"/>
+                    </a:lnR>
+                    <a:lnT w="12700" cap="flat" cmpd="sng" algn="ctr">
+                      <a:solidFill>
+                        <a:srgbClr val="DCE4F0"/>
+                      </a:solidFill>
+                      <a:prstDash val="solid"/>
+                      <a:round/>
+                      <a:headEnd type="none" w="med" len="med"/>
+                      <a:tailEnd type="none" w="med" len="med"/>
+                    </a:lnT>
+                    <a:lnB w="12700" cap="flat" cmpd="sng" algn="ctr">
+                      <a:solidFill>
+                        <a:srgbClr val="DCE4F0"/>
+                      </a:solidFill>
+                      <a:prstDash val="solid"/>
+                      <a:round/>
+                      <a:headEnd type="none" w="med" len="med"/>
+                      <a:tailEnd type="none" w="med" len="med"/>
+                    </a:lnB>
+                  </a:tcPr>
+                </a:tc>
+                <a:tc>
+                  <a:txBody>
+                    <a:bodyPr/>
+                    <a:lstStyle/>
+                    <a:p>
+                      <a:pPr indent="0" marL="0">
+                        <a:buNone/>
+                      </a:pPr>
+                      <a:r>
+                        <a:rPr lang="en-US" sz="1050" dirty="0">
+                          <a:solidFill>
+                            <a:srgbClr val="232833"/>
+                          </a:solidFill>
+                          <a:latin typeface="Calibri" pitchFamily="34" charset="0"/>
+                          <a:ea typeface="Calibri" pitchFamily="34" charset="-122"/>
+                          <a:cs typeface="Calibri" pitchFamily="34" charset="-120"/>
+                        </a:rPr>
+                        <a:t>0.789 ± 0.010</a:t>
+                      </a:r>
+                      <a:endParaRPr lang="en-US" sz="1050" dirty="0">
+                        <a:latin typeface="Calibri" charset="0"/>
+                        <a:ea typeface="Calibri" charset="0"/>
+                        <a:cs typeface="Calibri" charset="0"/>
+                      </a:endParaRPr>
+                    </a:p>
+                  </a:txBody>
+                  <a:tcPr marL="45720" marR="45720" marT="45720" marB="45720" anchor="ctr">
+                    <a:lnL w="12700" cap="flat" cmpd="sng" algn="ctr">
+                      <a:solidFill>
+                        <a:srgbClr val="DCE4F0"/>
+                      </a:solidFill>
+                      <a:prstDash val="solid"/>
+                      <a:round/>
+                      <a:headEnd type="none" w="med" len="med"/>
+                      <a:tailEnd type="none" w="med" len="med"/>
+                    </a:lnL>
+                    <a:lnR w="12700" cap="flat" cmpd="sng" algn="ctr">
+                      <a:solidFill>
+                        <a:srgbClr val="DCE4F0"/>
+                      </a:solidFill>
+                      <a:prstDash val="solid"/>
+                      <a:round/>
+                      <a:headEnd type="none" w="med" len="med"/>
+                      <a:tailEnd type="none" w="med" len="med"/>
+                    </a:lnR>
+                    <a:lnT w="12700" cap="flat" cmpd="sng" algn="ctr">
+                      <a:solidFill>
+                        <a:srgbClr val="DCE4F0"/>
+                      </a:solidFill>
+                      <a:prstDash val="solid"/>
+                      <a:round/>
+                      <a:headEnd type="none" w="med" len="med"/>
+                      <a:tailEnd type="none" w="med" len="med"/>
+                    </a:lnT>
+                    <a:lnB w="12700" cap="flat" cmpd="sng" algn="ctr">
+                      <a:solidFill>
+                        <a:srgbClr val="DCE4F0"/>
+                      </a:solidFill>
+                      <a:prstDash val="solid"/>
+                      <a:round/>
+                      <a:headEnd type="none" w="med" len="med"/>
+                      <a:tailEnd type="none" w="med" len="med"/>
+                    </a:lnB>
+                  </a:tcPr>
+                </a:tc>
+                <a:tc>
+                  <a:txBody>
+                    <a:bodyPr/>
+                    <a:lstStyle/>
+                    <a:p>
+                      <a:pPr indent="0" marL="0">
+                        <a:buNone/>
+                      </a:pPr>
+                      <a:r>
+                        <a:rPr lang="en-US" sz="1050" dirty="0">
+                          <a:solidFill>
+                            <a:srgbClr val="232833"/>
+                          </a:solidFill>
+                          <a:latin typeface="Calibri" pitchFamily="34" charset="0"/>
+                          <a:ea typeface="Calibri" pitchFamily="34" charset="-122"/>
+                          <a:cs typeface="Calibri" pitchFamily="34" charset="-120"/>
+                        </a:rPr>
+                        <a:t>0.759 ± 0.052</a:t>
+                      </a:r>
+                      <a:endParaRPr lang="en-US" sz="1050" dirty="0">
+                        <a:latin typeface="Calibri" charset="0"/>
+                        <a:ea typeface="Calibri" charset="0"/>
+                        <a:cs typeface="Calibri" charset="0"/>
+                      </a:endParaRPr>
+                    </a:p>
+                  </a:txBody>
+                  <a:tcPr marL="45720" marR="45720" marT="45720" marB="45720" anchor="ctr">
+                    <a:lnL w="12700" cap="flat" cmpd="sng" algn="ctr">
+                      <a:solidFill>
+                        <a:srgbClr val="DCE4F0"/>
+                      </a:solidFill>
+                      <a:prstDash val="solid"/>
+                      <a:round/>
+                      <a:headEnd type="none" w="med" len="med"/>
+                      <a:tailEnd type="none" w="med" len="med"/>
+                    </a:lnL>
+                    <a:lnR w="12700" cap="flat" cmpd="sng" algn="ctr">
+                      <a:solidFill>
+                        <a:srgbClr val="DCE4F0"/>
+                      </a:solidFill>
+                      <a:prstDash val="solid"/>
+                      <a:round/>
+                      <a:headEnd type="none" w="med" len="med"/>
+                      <a:tailEnd type="none" w="med" len="med"/>
+                    </a:lnR>
+                    <a:lnT w="12700" cap="flat" cmpd="sng" algn="ctr">
+                      <a:solidFill>
+                        <a:srgbClr val="DCE4F0"/>
+                      </a:solidFill>
+                      <a:prstDash val="solid"/>
+                      <a:round/>
+                      <a:headEnd type="none" w="med" len="med"/>
+                      <a:tailEnd type="none" w="med" len="med"/>
+                    </a:lnT>
+                    <a:lnB w="12700" cap="flat" cmpd="sng" algn="ctr">
+                      <a:solidFill>
+                        <a:srgbClr val="DCE4F0"/>
+                      </a:solidFill>
+                      <a:prstDash val="solid"/>
+                      <a:round/>
+                      <a:headEnd type="none" w="med" len="med"/>
+                      <a:tailEnd type="none" w="med" len="med"/>
+                    </a:lnB>
+                  </a:tcPr>
+                </a:tc>
+              </a:tr>
+              <a:tr h="329184">
+                <a:tc>
+                  <a:txBody>
+                    <a:bodyPr/>
+                    <a:lstStyle/>
+                    <a:p>
+                      <a:pPr indent="0" marL="0">
+                        <a:buNone/>
+                      </a:pPr>
+                      <a:r>
+                        <a:rPr lang="en-US" sz="1050" dirty="0">
+                          <a:solidFill>
+                            <a:srgbClr val="232833"/>
+                          </a:solidFill>
+                          <a:latin typeface="Calibri" pitchFamily="34" charset="0"/>
+                          <a:ea typeface="Calibri" pitchFamily="34" charset="-122"/>
+                          <a:cs typeface="Calibri" pitchFamily="34" charset="-120"/>
+                        </a:rPr>
+                        <a:t>fake rate</a:t>
+                      </a:r>
+                      <a:endParaRPr lang="en-US" sz="1050" dirty="0">
+                        <a:latin typeface="Calibri" charset="0"/>
+                        <a:ea typeface="Calibri" charset="0"/>
+                        <a:cs typeface="Calibri" charset="0"/>
+                      </a:endParaRPr>
+                    </a:p>
+                  </a:txBody>
+                  <a:tcPr marL="45720" marR="45720" marT="45720" marB="45720" anchor="ctr">
+                    <a:lnL w="12700" cap="flat" cmpd="sng" algn="ctr">
+                      <a:solidFill>
+                        <a:srgbClr val="DCE4F0"/>
+                      </a:solidFill>
+                      <a:prstDash val="solid"/>
+                      <a:round/>
+                      <a:headEnd type="none" w="med" len="med"/>
+                      <a:tailEnd type="none" w="med" len="med"/>
+                    </a:lnL>
+                    <a:lnR w="12700" cap="flat" cmpd="sng" algn="ctr">
+                      <a:solidFill>
+                        <a:srgbClr val="DCE4F0"/>
+                      </a:solidFill>
+                      <a:prstDash val="solid"/>
+                      <a:round/>
+                      <a:headEnd type="none" w="med" len="med"/>
+                      <a:tailEnd type="none" w="med" len="med"/>
+                    </a:lnR>
+                    <a:lnT w="12700" cap="flat" cmpd="sng" algn="ctr">
+                      <a:solidFill>
+                        <a:srgbClr val="DCE4F0"/>
+                      </a:solidFill>
+                      <a:prstDash val="solid"/>
+                      <a:round/>
+                      <a:headEnd type="none" w="med" len="med"/>
+                      <a:tailEnd type="none" w="med" len="med"/>
+                    </a:lnT>
+                    <a:lnB w="12700" cap="flat" cmpd="sng" algn="ctr">
+                      <a:solidFill>
+                        <a:srgbClr val="DCE4F0"/>
+                      </a:solidFill>
+                      <a:prstDash val="solid"/>
+                      <a:round/>
+                      <a:headEnd type="none" w="med" len="med"/>
+                      <a:tailEnd type="none" w="med" len="med"/>
+                    </a:lnB>
+                  </a:tcPr>
+                </a:tc>
+                <a:tc>
+                  <a:txBody>
+                    <a:bodyPr/>
+                    <a:lstStyle/>
+                    <a:p>
+                      <a:pPr indent="0" marL="0">
+                        <a:buNone/>
+                      </a:pPr>
+                      <a:r>
+                        <a:rPr lang="en-US" sz="1050" dirty="0">
+                          <a:solidFill>
+                            <a:srgbClr val="232833"/>
+                          </a:solidFill>
+                          <a:latin typeface="Calibri" pitchFamily="34" charset="0"/>
+                          <a:ea typeface="Calibri" pitchFamily="34" charset="-122"/>
+                          <a:cs typeface="Calibri" pitchFamily="34" charset="-120"/>
+                        </a:rPr>
+                        <a:t>0.125 ± 0.021</a:t>
+                      </a:r>
+                      <a:endParaRPr lang="en-US" sz="1050" dirty="0">
+                        <a:latin typeface="Calibri" charset="0"/>
+                        <a:ea typeface="Calibri" charset="0"/>
+                        <a:cs typeface="Calibri" charset="0"/>
+                      </a:endParaRPr>
+                    </a:p>
+                  </a:txBody>
+                  <a:tcPr marL="45720" marR="45720" marT="45720" marB="45720" anchor="ctr">
+                    <a:lnL w="12700" cap="flat" cmpd="sng" algn="ctr">
+                      <a:solidFill>
+                        <a:srgbClr val="DCE4F0"/>
+                      </a:solidFill>
+                      <a:prstDash val="solid"/>
+                      <a:round/>
+                      <a:headEnd type="none" w="med" len="med"/>
+                      <a:tailEnd type="none" w="med" len="med"/>
+                    </a:lnL>
+                    <a:lnR w="12700" cap="flat" cmpd="sng" algn="ctr">
+                      <a:solidFill>
+                        <a:srgbClr val="DCE4F0"/>
+                      </a:solidFill>
+                      <a:prstDash val="solid"/>
+                      <a:round/>
+                      <a:headEnd type="none" w="med" len="med"/>
+                      <a:tailEnd type="none" w="med" len="med"/>
+                    </a:lnR>
+                    <a:lnT w="12700" cap="flat" cmpd="sng" algn="ctr">
+                      <a:solidFill>
+                        <a:srgbClr val="DCE4F0"/>
+                      </a:solidFill>
+                      <a:prstDash val="solid"/>
+                      <a:round/>
+                      <a:headEnd type="none" w="med" len="med"/>
+                      <a:tailEnd type="none" w="med" len="med"/>
+                    </a:lnT>
+                    <a:lnB w="12700" cap="flat" cmpd="sng" algn="ctr">
+                      <a:solidFill>
+                        <a:srgbClr val="DCE4F0"/>
+                      </a:solidFill>
+                      <a:prstDash val="solid"/>
+                      <a:round/>
+                      <a:headEnd type="none" w="med" len="med"/>
+                      <a:tailEnd type="none" w="med" len="med"/>
+                    </a:lnB>
+                  </a:tcPr>
+                </a:tc>
+                <a:tc>
+                  <a:txBody>
+                    <a:bodyPr/>
+                    <a:lstStyle/>
+                    <a:p>
+                      <a:pPr indent="0" marL="0">
+                        <a:buNone/>
+                      </a:pPr>
+                      <a:r>
+                        <a:rPr lang="en-US" sz="1050" dirty="0">
+                          <a:solidFill>
+                            <a:srgbClr val="232833"/>
+                          </a:solidFill>
+                          <a:latin typeface="Calibri" pitchFamily="34" charset="0"/>
+                          <a:ea typeface="Calibri" pitchFamily="34" charset="-122"/>
+                          <a:cs typeface="Calibri" pitchFamily="34" charset="-120"/>
+                        </a:rPr>
+                        <a:t>0.110 ± 0.016</a:t>
+                      </a:r>
+                      <a:endParaRPr lang="en-US" sz="1050" dirty="0">
+                        <a:latin typeface="Calibri" charset="0"/>
+                        <a:ea typeface="Calibri" charset="0"/>
+                        <a:cs typeface="Calibri" charset="0"/>
+                      </a:endParaRPr>
+                    </a:p>
+                  </a:txBody>
+                  <a:tcPr marL="45720" marR="45720" marT="45720" marB="45720" anchor="ctr">
+                    <a:lnL w="12700" cap="flat" cmpd="sng" algn="ctr">
+                      <a:solidFill>
+                        <a:srgbClr val="DCE4F0"/>
+                      </a:solidFill>
+                      <a:prstDash val="solid"/>
+                      <a:round/>
+                      <a:headEnd type="none" w="med" len="med"/>
+                      <a:tailEnd type="none" w="med" len="med"/>
+                    </a:lnL>
+                    <a:lnR w="12700" cap="flat" cmpd="sng" algn="ctr">
+                      <a:solidFill>
+                        <a:srgbClr val="DCE4F0"/>
+                      </a:solidFill>
+                      <a:prstDash val="solid"/>
+                      <a:round/>
+                      <a:headEnd type="none" w="med" len="med"/>
+                      <a:tailEnd type="none" w="med" len="med"/>
+                    </a:lnR>
+                    <a:lnT w="12700" cap="flat" cmpd="sng" algn="ctr">
+                      <a:solidFill>
+                        <a:srgbClr val="DCE4F0"/>
+                      </a:solidFill>
+                      <a:prstDash val="solid"/>
+                      <a:round/>
+                      <a:headEnd type="none" w="med" len="med"/>
+                      <a:tailEnd type="none" w="med" len="med"/>
+                    </a:lnT>
+                    <a:lnB w="12700" cap="flat" cmpd="sng" algn="ctr">
+                      <a:solidFill>
+                        <a:srgbClr val="DCE4F0"/>
+                      </a:solidFill>
+                      <a:prstDash val="solid"/>
+                      <a:round/>
+                      <a:headEnd type="none" w="med" len="med"/>
+                      <a:tailEnd type="none" w="med" len="med"/>
+                    </a:lnB>
+                  </a:tcPr>
+                </a:tc>
+              </a:tr>
+              <a:tr h="329184">
+                <a:tc>
+                  <a:txBody>
+                    <a:bodyPr/>
+                    <a:lstStyle/>
+                    <a:p>
+                      <a:pPr indent="0" marL="0">
+                        <a:buNone/>
+                      </a:pPr>
+                      <a:r>
+                        <a:rPr lang="en-US" sz="1050" dirty="0">
+                          <a:solidFill>
+                            <a:srgbClr val="232833"/>
+                          </a:solidFill>
+                          <a:latin typeface="Calibri" pitchFamily="34" charset="0"/>
+                          <a:ea typeface="Calibri" pitchFamily="34" charset="-122"/>
+                          <a:cs typeface="Calibri" pitchFamily="34" charset="-120"/>
+                        </a:rPr>
+                        <a:t>log-pT MAE (found)</a:t>
+                      </a:r>
+                      <a:endParaRPr lang="en-US" sz="1050" dirty="0">
+                        <a:latin typeface="Calibri" charset="0"/>
+                        <a:ea typeface="Calibri" charset="0"/>
+                        <a:cs typeface="Calibri" charset="0"/>
+                      </a:endParaRPr>
+                    </a:p>
+                  </a:txBody>
+                  <a:tcPr marL="45720" marR="45720" marT="45720" marB="45720" anchor="ctr">
+                    <a:lnL w="12700" cap="flat" cmpd="sng" algn="ctr">
+                      <a:solidFill>
+                        <a:srgbClr val="DCE4F0"/>
+                      </a:solidFill>
+                      <a:prstDash val="solid"/>
+                      <a:round/>
+                      <a:headEnd type="none" w="med" len="med"/>
+                      <a:tailEnd type="none" w="med" len="med"/>
+                    </a:lnL>
+                    <a:lnR w="12700" cap="flat" cmpd="sng" algn="ctr">
+                      <a:solidFill>
+                        <a:srgbClr val="DCE4F0"/>
+                      </a:solidFill>
+                      <a:prstDash val="solid"/>
+                      <a:round/>
+                      <a:headEnd type="none" w="med" len="med"/>
+                      <a:tailEnd type="none" w="med" len="med"/>
+                    </a:lnR>
+                    <a:lnT w="12700" cap="flat" cmpd="sng" algn="ctr">
+                      <a:solidFill>
+                        <a:srgbClr val="DCE4F0"/>
+                      </a:solidFill>
+                      <a:prstDash val="solid"/>
+                      <a:round/>
+                      <a:headEnd type="none" w="med" len="med"/>
+                      <a:tailEnd type="none" w="med" len="med"/>
+                    </a:lnT>
+                    <a:lnB w="12700" cap="flat" cmpd="sng" algn="ctr">
+                      <a:solidFill>
+                        <a:srgbClr val="DCE4F0"/>
+                      </a:solidFill>
+                      <a:prstDash val="solid"/>
+                      <a:round/>
+                      <a:headEnd type="none" w="med" len="med"/>
+                      <a:tailEnd type="none" w="med" len="med"/>
+                    </a:lnB>
+                  </a:tcPr>
+                </a:tc>
+                <a:tc>
+                  <a:txBody>
+                    <a:bodyPr/>
+                    <a:lstStyle/>
+                    <a:p>
+                      <a:pPr indent="0" marL="0">
+                        <a:buNone/>
+                      </a:pPr>
+                      <a:r>
+                        <a:rPr lang="en-US" sz="1050" dirty="0">
+                          <a:solidFill>
+                            <a:srgbClr val="232833"/>
+                          </a:solidFill>
+                          <a:latin typeface="Calibri" pitchFamily="34" charset="0"/>
+                          <a:ea typeface="Calibri" pitchFamily="34" charset="-122"/>
+                          <a:cs typeface="Calibri" pitchFamily="34" charset="-120"/>
+                        </a:rPr>
+                        <a:t>0.293 ± 0.010</a:t>
+                      </a:r>
+                      <a:endParaRPr lang="en-US" sz="1050" dirty="0">
+                        <a:latin typeface="Calibri" charset="0"/>
+                        <a:ea typeface="Calibri" charset="0"/>
+                        <a:cs typeface="Calibri" charset="0"/>
+                      </a:endParaRPr>
+                    </a:p>
+                  </a:txBody>
+                  <a:tcPr marL="45720" marR="45720" marT="45720" marB="45720" anchor="ctr">
+                    <a:lnL w="12700" cap="flat" cmpd="sng" algn="ctr">
+                      <a:solidFill>
+                        <a:srgbClr val="DCE4F0"/>
+                      </a:solidFill>
+                      <a:prstDash val="solid"/>
+                      <a:round/>
+                      <a:headEnd type="none" w="med" len="med"/>
+                      <a:tailEnd type="none" w="med" len="med"/>
+                    </a:lnL>
+                    <a:lnR w="12700" cap="flat" cmpd="sng" algn="ctr">
+                      <a:solidFill>
+                        <a:srgbClr val="DCE4F0"/>
+                      </a:solidFill>
+                      <a:prstDash val="solid"/>
+                      <a:round/>
+                      <a:headEnd type="none" w="med" len="med"/>
+                      <a:tailEnd type="none" w="med" len="med"/>
+                    </a:lnR>
+                    <a:lnT w="12700" cap="flat" cmpd="sng" algn="ctr">
+                      <a:solidFill>
+                        <a:srgbClr val="DCE4F0"/>
+                      </a:solidFill>
+                      <a:prstDash val="solid"/>
+                      <a:round/>
+                      <a:headEnd type="none" w="med" len="med"/>
+                      <a:tailEnd type="none" w="med" len="med"/>
+                    </a:lnT>
+                    <a:lnB w="12700" cap="flat" cmpd="sng" algn="ctr">
+                      <a:solidFill>
+                        <a:srgbClr val="DCE4F0"/>
+                      </a:solidFill>
+                      <a:prstDash val="solid"/>
+                      <a:round/>
+                      <a:headEnd type="none" w="med" len="med"/>
+                      <a:tailEnd type="none" w="med" len="med"/>
+                    </a:lnB>
+                  </a:tcPr>
+                </a:tc>
+                <a:tc>
+                  <a:txBody>
+                    <a:bodyPr/>
+                    <a:lstStyle/>
+                    <a:p>
+                      <a:pPr indent="0" marL="0">
+                        <a:buNone/>
+                      </a:pPr>
+                      <a:r>
+                        <a:rPr lang="en-US" sz="1050" dirty="0">
+                          <a:solidFill>
+                            <a:srgbClr val="232833"/>
+                          </a:solidFill>
+                          <a:latin typeface="Calibri" pitchFamily="34" charset="0"/>
+                          <a:ea typeface="Calibri" pitchFamily="34" charset="-122"/>
+                          <a:cs typeface="Calibri" pitchFamily="34" charset="-120"/>
+                        </a:rPr>
+                        <a:t>0.238 ± 0.015</a:t>
+                      </a:r>
+                      <a:endParaRPr lang="en-US" sz="1050" dirty="0">
+                        <a:latin typeface="Calibri" charset="0"/>
+                        <a:ea typeface="Calibri" charset="0"/>
+                        <a:cs typeface="Calibri" charset="0"/>
+                      </a:endParaRPr>
+                    </a:p>
+                  </a:txBody>
+                  <a:tcPr marL="45720" marR="45720" marT="45720" marB="45720" anchor="ctr">
+                    <a:lnL w="12700" cap="flat" cmpd="sng" algn="ctr">
+                      <a:solidFill>
+                        <a:srgbClr val="DCE4F0"/>
+                      </a:solidFill>
+                      <a:prstDash val="solid"/>
+                      <a:round/>
+                      <a:headEnd type="none" w="med" len="med"/>
+                      <a:tailEnd type="none" w="med" len="med"/>
+                    </a:lnL>
+                    <a:lnR w="12700" cap="flat" cmpd="sng" algn="ctr">
+                      <a:solidFill>
+                        <a:srgbClr val="DCE4F0"/>
+                      </a:solidFill>
+                      <a:prstDash val="solid"/>
+                      <a:round/>
+                      <a:headEnd type="none" w="med" len="med"/>
+                      <a:tailEnd type="none" w="med" len="med"/>
+                    </a:lnR>
+                    <a:lnT w="12700" cap="flat" cmpd="sng" algn="ctr">
+                      <a:solidFill>
+                        <a:srgbClr val="DCE4F0"/>
+                      </a:solidFill>
+                      <a:prstDash val="solid"/>
+                      <a:round/>
+                      <a:headEnd type="none" w="med" len="med"/>
+                      <a:tailEnd type="none" w="med" len="med"/>
+                    </a:lnT>
+                    <a:lnB w="12700" cap="flat" cmpd="sng" algn="ctr">
+                      <a:solidFill>
+                        <a:srgbClr val="DCE4F0"/>
+                      </a:solidFill>
+                      <a:prstDash val="solid"/>
+                      <a:round/>
+                      <a:headEnd type="none" w="med" len="med"/>
+                      <a:tailEnd type="none" w="med" len="med"/>
+                    </a:lnB>
+                  </a:tcPr>
+                </a:tc>
+              </a:tr>
+            </a:tbl>
+          </a:graphicData>
+        </a:graphic>
+      </p:graphicFrame>
+      <p:sp>
+        <p:nvSpPr>
+          <p:cNvPr id="6" name="Text 3"/>
+          <p:cNvSpPr/>
+          <p:nvPr/>
+        </p:nvSpPr>
+        <p:spPr>
+          <a:xfrm>
+            <a:off x="502920" y="4206240"/>
+            <a:ext cx="5943600" cy="1737360"/>
+          </a:xfrm>
+          <a:prstGeom prst="rect">
+            <a:avLst/>
+          </a:prstGeom>
+          <a:noFill/>
+          <a:ln/>
+        </p:spPr>
+        <p:txBody>
+          <a:bodyPr wrap="square" lIns="0" tIns="0" rIns="0" bIns="0" rtlCol="0" anchor="t"/>
+          <a:lstStyle/>
+          <a:p>
+            <a:pPr marL="127000" indent="-127000">
+              <a:lnSpc>
+                <a:spcPct val="107000"/>
+              </a:lnSpc>
+              <a:buSzPct val="100000"/>
+              <a:buChar char="•"/>
+            </a:pPr>
+            <a:r>
+              <a:rPr lang="en-US" sz="1200" b="1" dirty="0">
+                <a:solidFill>
+                  <a:srgbClr val="1E2761"/>
+                </a:solidFill>
+                <a:latin typeface="Calibri" pitchFamily="34" charset="0"/>
+                <a:ea typeface="Calibri" pitchFamily="34" charset="-122"/>
+                <a:cs typeface="Calibri" pitchFamily="34" charset="-120"/>
+              </a:rPr>
+              <a:t>Read the profile, not the integral:</a:t>
+            </a:r>
+            <a:pPr indent="0" marL="0">
+              <a:lnSpc>
+                <a:spcPct val="107000"/>
+              </a:lnSpc>
+              <a:spcAft>
+                <a:spcPts val="800"/>
+              </a:spcAft>
+              <a:buNone/>
+            </a:pPr>
+            <a:r>
+              <a:rPr lang="en-US" sz="1200" dirty="0">
+                <a:solidFill>
+                  <a:srgbClr val="232833"/>
+                </a:solidFill>
+                <a:latin typeface="Calibri" pitchFamily="34" charset="0"/>
+                <a:ea typeface="Calibri" pitchFamily="34" charset="-122"/>
+                <a:cs typeface="Calibri" pitchFamily="34" charset="-120"/>
+              </a:rPr>
+              <a:t> the scalar efficiency is dominated by the 20–30 GeV turn-on; at plateau (&gt; 80 GeV) the best seed reaches 0.99 with cells vs 0.95 without, and cells sharpen the found-jet kinematics.</a:t>
+            </a:r>
+            <a:endParaRPr lang="en-US" sz="1200" dirty="0"/>
+          </a:p>
+          <a:p>
+            <a:pPr marL="127000" indent="-127000">
+              <a:lnSpc>
+                <a:spcPct val="107000"/>
+              </a:lnSpc>
+              <a:buSzPct val="100000"/>
+              <a:buChar char="•"/>
+            </a:pPr>
+            <a:r>
+              <a:rPr lang="en-US" sz="1200" b="1" dirty="0">
+                <a:solidFill>
+                  <a:srgbClr val="1E2761"/>
+                </a:solidFill>
+                <a:latin typeface="Calibri" pitchFamily="34" charset="0"/>
+                <a:ea typeface="Calibri" pitchFamily="34" charset="-122"/>
+                <a:cs typeface="Calibri" pitchFamily="34" charset="-120"/>
+              </a:rPr>
+              <a:t>DETR instability is real:</a:t>
+            </a:r>
+            <a:pPr indent="0" marL="0">
+              <a:lnSpc>
+                <a:spcPct val="107000"/>
+              </a:lnSpc>
+              <a:spcAft>
+                <a:spcPts val="800"/>
+              </a:spcAft>
+              <a:buNone/>
+            </a:pPr>
+            <a:r>
+              <a:rPr lang="en-US" sz="1200" dirty="0">
+                <a:solidFill>
+                  <a:srgbClr val="232833"/>
+                </a:solidFill>
+                <a:latin typeface="Calibri" pitchFamily="34" charset="0"/>
+                <a:ea typeface="Calibri" pitchFamily="34" charset="-122"/>
+                <a:cs typeface="Calibri" pitchFamily="34" charset="-120"/>
+              </a:rPr>
+              <a:t> large seed variance with cells (best-seed val 1.31 vs 1.71) — matching-stabilization techniques are the known fix and the obvious next step.</a:t>
+            </a:r>
+            <a:endParaRPr lang="en-US" sz="1200" dirty="0"/>
+          </a:p>
+        </p:txBody>
+      </p:sp>
+      <p:sp>
+        <p:nvSpPr>
+          <p:cNvPr id="7" name="Text 4"/>
+          <p:cNvSpPr/>
+          <p:nvPr/>
+        </p:nvSpPr>
+        <p:spPr>
+          <a:xfrm>
+            <a:off x="502920" y="6035040"/>
+            <a:ext cx="5943600" cy="411480"/>
+          </a:xfrm>
+          <a:prstGeom prst="rect">
+            <a:avLst/>
+          </a:prstGeom>
+          <a:noFill/>
+          <a:ln/>
+        </p:spPr>
+        <p:txBody>
+          <a:bodyPr wrap="square" lIns="0" tIns="0" rIns="0" bIns="0" rtlCol="0" anchor="ctr"/>
+          <a:lstStyle/>
+          <a:p>
+            <a:pPr indent="0" marL="0">
+              <a:buNone/>
+            </a:pPr>
+            <a:r>
+              <a:rPr lang="en-US" sz="950" i="1" dirty="0">
+                <a:solidFill>
+                  <a:srgbClr val="667085"/>
+                </a:solidFill>
+                <a:latin typeface="Calibri" pitchFamily="34" charset="0"/>
+                <a:ea typeface="Calibri" pitchFamily="34" charset="-122"/>
+                <a:cs typeface="Calibri" pitchFamily="34" charset="-120"/>
+              </a:rPr>
+              <a:t>Rerun note: TC seeds trained under torch 2.13 after the reboot-forced venv rebuild; no checkpoints cross versions.</a:t>
+            </a:r>
+            <a:endParaRPr lang="en-US" sz="950" dirty="0"/>
+          </a:p>
+        </p:txBody>
+      </p:sp>
+      <p:pic>
+        <p:nvPicPr>
+          <p:cNvPr id="8" name="Image 0" descr="/private/tmp/claude-503/-Users-afarbin-CaloGNN-CaloGraphNet/641347a1-f97c-4347-b083-6ec9af739b1e/scratchpad/t34/T4A_efficiency.png">    </p:cNvPr>
+          <p:cNvPicPr>
+            <a:picLocks noChangeAspect="1"/>
+          </p:cNvPicPr>
+          <p:nvPr/>
+        </p:nvPicPr>
+        <p:blipFill>
+          <a:blip r:embed="rId1"/>
+          <a:stretch>
+            <a:fillRect/>
+          </a:stretch>
+        </p:blipFill>
+        <p:spPr>
+          <a:xfrm>
+            <a:off x="6903720" y="1207008"/>
+            <a:ext cx="3291840" cy="2468880"/>
+          </a:xfrm>
+          <a:prstGeom prst="rect">
+            <a:avLst/>
+          </a:prstGeom>
+        </p:spPr>
+      </p:pic>
+      <p:pic>
+        <p:nvPicPr>
+          <p:cNvPr id="9" name="Image 1" descr="/private/tmp/claude-503/-Users-afarbin-CaloGNN-CaloGraphNet/641347a1-f97c-4347-b083-6ec9af739b1e/scratchpad/t34/T4B_residuals.png">    </p:cNvPr>
+          <p:cNvPicPr>
+            <a:picLocks noChangeAspect="1"/>
+          </p:cNvPicPr>
+          <p:nvPr/>
+        </p:nvPicPr>
+        <p:blipFill>
+          <a:blip r:embed="rId2"/>
+          <a:stretch>
+            <a:fillRect/>
+          </a:stretch>
+        </p:blipFill>
+        <p:spPr>
+          <a:xfrm>
+            <a:off x="6903720" y="3822192"/>
+            <a:ext cx="3291840" cy="2468880"/>
+          </a:xfrm>
+          <a:prstGeom prst="rect">
+            <a:avLst/>
+          </a:prstGeom>
+        </p:spPr>
+      </p:pic>
+      <p:sp>
+        <p:nvSpPr>
+          <p:cNvPr id="10" name="Text 5"/>
+          <p:cNvSpPr/>
+          <p:nvPr/>
+        </p:nvSpPr>
+        <p:spPr>
+          <a:xfrm>
+            <a:off x="6675120" y="6355080"/>
+            <a:ext cx="5120640" cy="292608"/>
+          </a:xfrm>
+          <a:prstGeom prst="rect">
+            <a:avLst/>
+          </a:prstGeom>
+          <a:noFill/>
+          <a:ln/>
+        </p:spPr>
+        <p:txBody>
+          <a:bodyPr wrap="square" lIns="0" tIns="0" rIns="0" bIns="0" rtlCol="0" anchor="ctr"/>
+          <a:lstStyle/>
+          <a:p>
+            <a:pPr indent="0" marL="0">
+              <a:buNone/>
+            </a:pPr>
+            <a:r>
+              <a:rPr lang="en-US" sz="1000" i="1" dirty="0">
+                <a:solidFill>
+                  <a:srgbClr val="667085"/>
+                </a:solidFill>
+                <a:latin typeface="Calibri" pitchFamily="34" charset="0"/>
+                <a:ea typeface="Calibri" pitchFamily="34" charset="-122"/>
+                <a:cs typeface="Calibri" pitchFamily="34" charset="-120"/>
+              </a:rPr>
+              <a:t>Top: finding efficiency vs truth pT (best seed). Bottom: log-pT residual of found jets.</a:t>
+            </a:r>
+            <a:endParaRPr lang="en-US" sz="1000" dirty="0"/>
+          </a:p>
+        </p:txBody>
+      </p:sp>
+      <p:sp>
+        <p:nvSpPr>
+          <p:cNvPr id="11" name="Text 6"/>
+          <p:cNvSpPr/>
+          <p:nvPr/>
+        </p:nvSpPr>
+        <p:spPr>
+          <a:xfrm>
+            <a:off x="502920" y="6510528"/>
+            <a:ext cx="4114800" cy="274320"/>
+          </a:xfrm>
+          <a:prstGeom prst="rect">
+            <a:avLst/>
+          </a:prstGeom>
+          <a:noFill/>
+          <a:ln/>
+        </p:spPr>
+        <p:txBody>
+          <a:bodyPr wrap="square" lIns="0" tIns="0" rIns="0" bIns="0" rtlCol="0" anchor="ctr"/>
+          <a:lstStyle/>
+          <a:p>
+            <a:pPr indent="0" marL="0">
+              <a:buNone/>
+            </a:pPr>
+            <a:r>
+              <a:rPr lang="en-US" sz="900" dirty="0">
+                <a:solidFill>
+                  <a:srgbClr val="667085"/>
+                </a:solidFill>
+                <a:latin typeface="Calibri" pitchFamily="34" charset="0"/>
+                <a:ea typeface="Calibri" pitchFamily="34" charset="-122"/>
+                <a:cs typeface="Calibri" pitchFamily="34" charset="-120"/>
+              </a:rPr>
+              <a:t>DFM feasibility — UT Arlington · Aug 2026</a:t>
+            </a:r>
+            <a:endParaRPr lang="en-US" sz="900" dirty="0"/>
+          </a:p>
+        </p:txBody>
+      </p:sp>
+      <p:sp>
+        <p:nvSpPr>
+          <p:cNvPr id="12" name="Text 7"/>
+          <p:cNvSpPr/>
+          <p:nvPr/>
+        </p:nvSpPr>
+        <p:spPr>
+          <a:xfrm>
+            <a:off x="11430000" y="6510528"/>
+            <a:ext cx="365760" cy="274320"/>
+          </a:xfrm>
+          <a:prstGeom prst="rect">
+            <a:avLst/>
+          </a:prstGeom>
+          <a:noFill/>
+          <a:ln/>
+        </p:spPr>
+        <p:txBody>
+          <a:bodyPr wrap="square" lIns="0" tIns="0" rIns="0" bIns="0" rtlCol="0" anchor="ctr"/>
+          <a:lstStyle/>
+          <a:p>
+            <a:pPr algn="r" indent="0" marL="0">
+              <a:buNone/>
+            </a:pPr>
+            <a:r>
+              <a:rPr lang="en-US" sz="900" dirty="0">
+                <a:solidFill>
+                  <a:srgbClr val="667085"/>
+                </a:solidFill>
+                <a:latin typeface="Calibri" pitchFamily="34" charset="0"/>
+                <a:ea typeface="Calibri" pitchFamily="34" charset="-122"/>
+                <a:cs typeface="Calibri" pitchFamily="34" charset="-120"/>
+              </a:rPr>
+              <a:t>17</a:t>
             </a:r>
             <a:endParaRPr lang="en-US" sz="900" dirty="0"/>
           </a:p>

</xml_diff>